<commit_message>
Add new slide layouts and enhance PowerPoint template with introduction and technical decision slides
</commit_message>
<xml_diff>
--- a/assets/templates/sourcier-blog-template.pptx
+++ b/assets/templates/sourcier-blog-template.pptx
@@ -11,9 +11,12 @@
     <p:sldId id="259" r:id="rId5"/>
     <p:sldId id="260" r:id="rId6"/>
     <p:sldId id="261" r:id="rId7"/>
+    <p:sldId id="262" r:id="rId8"/>
+    <p:sldId id="263" r:id="rId9"/>
+    <p:sldId id="264" r:id="rId10"/>
   </p:sldIdLst>
   <p:notesMasterIdLst>
-    <p:notesMasterId r:id="rId8"/>
+    <p:notesMasterId r:id="rId11"/>
   </p:notesMasterIdLst>
   <p:sldSz cx="12192000" cy="6858000"/>
   <p:notesSz cx="6858000" cy="12192000"/>
@@ -971,6 +974,270 @@
             <a:fld id="{F7021451-1387-4CA6-816F-3879F97B5CBC}" type="slidenum">
               <a:rPr lang="en-US"/>
               <a:t>6</a:t>
+            </a:fld>
+            <a:endParaRPr lang="en-US"/>
+          </a:p>
+        </p:txBody>
+      </p:sp>
+    </p:spTree>
+    <p:extLst>
+      <p:ext uri="{BB962C8B-B14F-4D97-AF65-F5344CB8AC3E}">
+        <p14:creationId xmlns:p14="http://schemas.microsoft.com/office/powerpoint/2010/main" val="1024086991"/>
+      </p:ext>
+    </p:extLst>
+  </p:cSld>
+  <p:clrMapOvr>
+    <a:masterClrMapping/>
+  </p:clrMapOvr>
+</p:notes>
+</file>
+
+<file path=ppt/notesSlides/notesSlide7.xml><?xml version="1.0" encoding="utf-8"?>
+<p:notes xmlns:a="http://schemas.openxmlformats.org/drawingml/2006/main" xmlns:r="http://schemas.openxmlformats.org/officeDocument/2006/relationships" xmlns:p="http://schemas.openxmlformats.org/presentationml/2006/main">
+  <p:cSld>
+    <p:spTree>
+      <p:nvGrpSpPr>
+        <p:cNvPr id="1" name=""/>
+        <p:cNvGrpSpPr/>
+        <p:nvPr/>
+      </p:nvGrpSpPr>
+      <p:grpSpPr>
+        <a:xfrm>
+          <a:off x="0" y="0"/>
+          <a:ext cx="0" cy="0"/>
+          <a:chOff x="0" y="0"/>
+          <a:chExt cx="0" cy="0"/>
+        </a:xfrm>
+      </p:grpSpPr>
+      <p:sp>
+        <p:nvSpPr>
+          <p:cNvPr id="2" name="Slide Image Placeholder 1"/>
+          <p:cNvSpPr>
+            <a:spLocks noGrp="1" noRot="1" noChangeAspect="1"/>
+          </p:cNvSpPr>
+          <p:nvPr>
+            <p:ph type="sldImg"/>
+          </p:nvPr>
+        </p:nvSpPr>
+        <p:spPr/>
+      </p:sp>
+      <p:sp>
+        <p:nvSpPr>
+          <p:cNvPr id="3" name="Notes Placeholder 2"/>
+          <p:cNvSpPr>
+            <a:spLocks noGrp="1"/>
+          </p:cNvSpPr>
+          <p:nvPr>
+            <p:ph type="body" idx="1"/>
+          </p:nvPr>
+        </p:nvSpPr>
+        <p:spPr/>
+        <p:txBody>
+          <a:bodyPr/>
+          <a:lstStyle/>
+          <a:p>
+            <a:r>
+              <a:rPr lang="en-US" dirty="0"/>
+              <a:t/>
+            </a:r>
+            <a:endParaRPr lang="en-US" dirty="0"/>
+          </a:p>
+        </p:txBody>
+      </p:sp>
+      <p:sp>
+        <p:nvSpPr>
+          <p:cNvPr id="4" name="Slide Number Placeholder 3"/>
+          <p:cNvSpPr>
+            <a:spLocks noGrp="1"/>
+          </p:cNvSpPr>
+          <p:nvPr>
+            <p:ph type="sldNum" sz="quarter" idx="10"/>
+          </p:nvPr>
+        </p:nvSpPr>
+        <p:spPr/>
+        <p:txBody>
+          <a:bodyPr/>
+          <a:lstStyle/>
+          <a:p>
+            <a:fld id="{F7021451-1387-4CA6-816F-3879F97B5CBC}" type="slidenum">
+              <a:rPr lang="en-US"/>
+              <a:t>7</a:t>
+            </a:fld>
+            <a:endParaRPr lang="en-US"/>
+          </a:p>
+        </p:txBody>
+      </p:sp>
+    </p:spTree>
+    <p:extLst>
+      <p:ext uri="{BB962C8B-B14F-4D97-AF65-F5344CB8AC3E}">
+        <p14:creationId xmlns:p14="http://schemas.microsoft.com/office/powerpoint/2010/main" val="1024086991"/>
+      </p:ext>
+    </p:extLst>
+  </p:cSld>
+  <p:clrMapOvr>
+    <a:masterClrMapping/>
+  </p:clrMapOvr>
+</p:notes>
+</file>
+
+<file path=ppt/notesSlides/notesSlide8.xml><?xml version="1.0" encoding="utf-8"?>
+<p:notes xmlns:a="http://schemas.openxmlformats.org/drawingml/2006/main" xmlns:r="http://schemas.openxmlformats.org/officeDocument/2006/relationships" xmlns:p="http://schemas.openxmlformats.org/presentationml/2006/main">
+  <p:cSld>
+    <p:spTree>
+      <p:nvGrpSpPr>
+        <p:cNvPr id="1" name=""/>
+        <p:cNvGrpSpPr/>
+        <p:nvPr/>
+      </p:nvGrpSpPr>
+      <p:grpSpPr>
+        <a:xfrm>
+          <a:off x="0" y="0"/>
+          <a:ext cx="0" cy="0"/>
+          <a:chOff x="0" y="0"/>
+          <a:chExt cx="0" cy="0"/>
+        </a:xfrm>
+      </p:grpSpPr>
+      <p:sp>
+        <p:nvSpPr>
+          <p:cNvPr id="2" name="Slide Image Placeholder 1"/>
+          <p:cNvSpPr>
+            <a:spLocks noGrp="1" noRot="1" noChangeAspect="1"/>
+          </p:cNvSpPr>
+          <p:nvPr>
+            <p:ph type="sldImg"/>
+          </p:nvPr>
+        </p:nvSpPr>
+        <p:spPr/>
+      </p:sp>
+      <p:sp>
+        <p:nvSpPr>
+          <p:cNvPr id="3" name="Notes Placeholder 2"/>
+          <p:cNvSpPr>
+            <a:spLocks noGrp="1"/>
+          </p:cNvSpPr>
+          <p:nvPr>
+            <p:ph type="body" idx="1"/>
+          </p:nvPr>
+        </p:nvSpPr>
+        <p:spPr/>
+        <p:txBody>
+          <a:bodyPr/>
+          <a:lstStyle/>
+          <a:p>
+            <a:r>
+              <a:rPr lang="en-US" dirty="0"/>
+              <a:t/>
+            </a:r>
+            <a:endParaRPr lang="en-US" dirty="0"/>
+          </a:p>
+        </p:txBody>
+      </p:sp>
+      <p:sp>
+        <p:nvSpPr>
+          <p:cNvPr id="4" name="Slide Number Placeholder 3"/>
+          <p:cNvSpPr>
+            <a:spLocks noGrp="1"/>
+          </p:cNvSpPr>
+          <p:nvPr>
+            <p:ph type="sldNum" sz="quarter" idx="10"/>
+          </p:nvPr>
+        </p:nvSpPr>
+        <p:spPr/>
+        <p:txBody>
+          <a:bodyPr/>
+          <a:lstStyle/>
+          <a:p>
+            <a:fld id="{F7021451-1387-4CA6-816F-3879F97B5CBC}" type="slidenum">
+              <a:rPr lang="en-US"/>
+              <a:t>8</a:t>
+            </a:fld>
+            <a:endParaRPr lang="en-US"/>
+          </a:p>
+        </p:txBody>
+      </p:sp>
+    </p:spTree>
+    <p:extLst>
+      <p:ext uri="{BB962C8B-B14F-4D97-AF65-F5344CB8AC3E}">
+        <p14:creationId xmlns:p14="http://schemas.microsoft.com/office/powerpoint/2010/main" val="1024086991"/>
+      </p:ext>
+    </p:extLst>
+  </p:cSld>
+  <p:clrMapOvr>
+    <a:masterClrMapping/>
+  </p:clrMapOvr>
+</p:notes>
+</file>
+
+<file path=ppt/notesSlides/notesSlide9.xml><?xml version="1.0" encoding="utf-8"?>
+<p:notes xmlns:a="http://schemas.openxmlformats.org/drawingml/2006/main" xmlns:r="http://schemas.openxmlformats.org/officeDocument/2006/relationships" xmlns:p="http://schemas.openxmlformats.org/presentationml/2006/main">
+  <p:cSld>
+    <p:spTree>
+      <p:nvGrpSpPr>
+        <p:cNvPr id="1" name=""/>
+        <p:cNvGrpSpPr/>
+        <p:nvPr/>
+      </p:nvGrpSpPr>
+      <p:grpSpPr>
+        <a:xfrm>
+          <a:off x="0" y="0"/>
+          <a:ext cx="0" cy="0"/>
+          <a:chOff x="0" y="0"/>
+          <a:chExt cx="0" cy="0"/>
+        </a:xfrm>
+      </p:grpSpPr>
+      <p:sp>
+        <p:nvSpPr>
+          <p:cNvPr id="2" name="Slide Image Placeholder 1"/>
+          <p:cNvSpPr>
+            <a:spLocks noGrp="1" noRot="1" noChangeAspect="1"/>
+          </p:cNvSpPr>
+          <p:nvPr>
+            <p:ph type="sldImg"/>
+          </p:nvPr>
+        </p:nvSpPr>
+        <p:spPr/>
+      </p:sp>
+      <p:sp>
+        <p:nvSpPr>
+          <p:cNvPr id="3" name="Notes Placeholder 2"/>
+          <p:cNvSpPr>
+            <a:spLocks noGrp="1"/>
+          </p:cNvSpPr>
+          <p:nvPr>
+            <p:ph type="body" idx="1"/>
+          </p:nvPr>
+        </p:nvSpPr>
+        <p:spPr/>
+        <p:txBody>
+          <a:bodyPr/>
+          <a:lstStyle/>
+          <a:p>
+            <a:r>
+              <a:rPr lang="en-US" dirty="0"/>
+              <a:t/>
+            </a:r>
+            <a:endParaRPr lang="en-US" dirty="0"/>
+          </a:p>
+        </p:txBody>
+      </p:sp>
+      <p:sp>
+        <p:nvSpPr>
+          <p:cNvPr id="4" name="Slide Number Placeholder 3"/>
+          <p:cNvSpPr>
+            <a:spLocks noGrp="1"/>
+          </p:cNvSpPr>
+          <p:nvPr>
+            <p:ph type="sldNum" sz="quarter" idx="10"/>
+          </p:nvPr>
+        </p:nvSpPr>
+        <p:spPr/>
+        <p:txBody>
+          <a:bodyPr/>
+          <a:lstStyle/>
+          <a:p>
+            <a:fld id="{F7021451-1387-4CA6-816F-3879F97B5CBC}" type="slidenum">
+              <a:rPr lang="en-US"/>
+              <a:t>9</a:t>
             </a:fld>
             <a:endParaRPr lang="en-US"/>
           </a:p>
@@ -1905,7 +2172,7 @@
                 <a:ea typeface="Barlow Condensed" pitchFamily="34" charset="-122"/>
                 <a:cs typeface="Barlow Condensed" pitchFamily="34" charset="-120"/>
               </a:rPr>
-              <a:t>SECTION HEADING</a:t>
+              <a:t>ABOUT ME</a:t>
             </a:r>
             <a:endParaRPr lang="en-US" sz="3400" dirty="0"/>
           </a:p>
@@ -1944,7 +2211,7 @@
                 <a:ea typeface="Barlow" pitchFamily="34" charset="-122"/>
                 <a:cs typeface="Barlow" pitchFamily="34" charset="-120"/>
               </a:rPr>
-              <a:t>Use this slide to split major themes.</a:t>
+              <a:t>A quick introduction before we get started.</a:t>
             </a:r>
             <a:endParaRPr lang="en-US" sz="1800" dirty="0"/>
           </a:p>
@@ -1958,12 +2225,12 @@
         </p:nvSpPr>
         <p:spPr>
           <a:xfrm>
-            <a:off x="457200" y="2331720"/>
-            <a:ext cx="11277295" cy="3246120"/>
+            <a:off x="457200" y="2057400"/>
+            <a:ext cx="6583680" cy="4160520"/>
           </a:xfrm>
           <a:prstGeom prst="roundRect">
             <a:avLst>
-              <a:gd name="adj" fmla="val 2254"/>
+              <a:gd name="adj" fmla="val 2198"/>
             </a:avLst>
           </a:prstGeom>
           <a:solidFill>
@@ -1985,8 +2252,8 @@
         </p:nvSpPr>
         <p:spPr>
           <a:xfrm>
-            <a:off x="457200" y="2331720"/>
-            <a:ext cx="146304" cy="3246120"/>
+            <a:off x="457200" y="2057400"/>
+            <a:ext cx="128016" cy="4160520"/>
           </a:xfrm>
           <a:prstGeom prst="rect">
             <a:avLst/>
@@ -2010,8 +2277,8 @@
         </p:nvSpPr>
         <p:spPr>
           <a:xfrm>
-            <a:off x="960120" y="3063240"/>
-            <a:ext cx="8961120" cy="658368"/>
+            <a:off x="804672" y="2340864"/>
+            <a:ext cx="1554480" cy="219456"/>
           </a:xfrm>
           <a:prstGeom prst="rect">
             <a:avLst/>
@@ -2027,17 +2294,17 @@
               <a:buNone/>
             </a:pPr>
             <a:r>
-              <a:rPr lang="en-US" sz="4200" b="1" dirty="0">
-                <a:solidFill>
-                  <a:srgbClr val="0F0F0F"/>
+              <a:rPr lang="en-US" sz="1200" b="1" dirty="0">
+                <a:solidFill>
+                  <a:srgbClr val="1B5A40"/>
                 </a:solidFill>
                 <a:latin typeface="Barlow Condensed" pitchFamily="34" charset="0"/>
                 <a:ea typeface="Barlow Condensed" pitchFamily="34" charset="-122"/>
                 <a:cs typeface="Barlow Condensed" pitchFamily="34" charset="-120"/>
               </a:rPr>
-              <a:t>SECTION TITLE</a:t>
-            </a:r>
-            <a:endParaRPr lang="en-US" sz="4200" dirty="0"/>
+              <a:t>ABOUT ME</a:t>
+            </a:r>
+            <a:endParaRPr lang="en-US" sz="1200" dirty="0"/>
           </a:p>
         </p:txBody>
       </p:sp>
@@ -2049,8 +2316,8 @@
         </p:nvSpPr>
         <p:spPr>
           <a:xfrm>
-            <a:off x="960120" y="3840480"/>
-            <a:ext cx="9601200" cy="365760"/>
+            <a:off x="804672" y="2633472"/>
+            <a:ext cx="5303520" cy="475488"/>
           </a:xfrm>
           <a:prstGeom prst="rect">
             <a:avLst/>
@@ -2066,7 +2333,48 @@
               <a:buNone/>
             </a:pPr>
             <a:r>
-              <a:rPr lang="en-US" sz="1800" dirty="0">
+              <a:rPr lang="en-US" sz="3100" b="1" dirty="0">
+                <a:solidFill>
+                  <a:srgbClr val="0F0F0F"/>
+                </a:solidFill>
+                <a:latin typeface="Barlow Condensed" pitchFamily="34" charset="0"/>
+                <a:ea typeface="Barlow Condensed" pitchFamily="34" charset="-122"/>
+                <a:cs typeface="Barlow Condensed" pitchFamily="34" charset="-120"/>
+              </a:rPr>
+              <a:t>Roger Rajaratnam</a:t>
+            </a:r>
+            <a:endParaRPr lang="en-US" sz="3100" dirty="0"/>
+          </a:p>
+        </p:txBody>
+      </p:sp>
+      <p:sp>
+        <p:nvSpPr>
+          <p:cNvPr id="15" name="Text 13"/>
+          <p:cNvSpPr/>
+          <p:nvPr/>
+        </p:nvSpPr>
+        <p:spPr>
+          <a:xfrm>
+            <a:off x="804672" y="3163824"/>
+            <a:ext cx="5623560" cy="621792"/>
+          </a:xfrm>
+          <a:prstGeom prst="rect">
+            <a:avLst/>
+          </a:prstGeom>
+          <a:noFill/>
+          <a:ln/>
+        </p:spPr>
+        <p:txBody>
+          <a:bodyPr wrap="square" rtlCol="0" anchor="ctr">
+            <a:normAutofit/>
+          </a:bodyPr>
+          <a:lstStyle/>
+          <a:p>
+            <a:pPr indent="0" marL="0">
+              <a:buNone/>
+            </a:pPr>
+            <a:r>
+              <a:rPr lang="en-US" sz="1600" dirty="0">
                 <a:solidFill>
                   <a:srgbClr val="6B6B6B"/>
                 </a:solidFill>
@@ -2074,34 +2382,11 @@
                 <a:ea typeface="Barlow" pitchFamily="34" charset="-122"/>
                 <a:cs typeface="Barlow" pitchFamily="34" charset="-120"/>
               </a:rPr>
-              <a:t>Optional context line for this part of the deck</a:t>
-            </a:r>
-            <a:endParaRPr lang="en-US" sz="1800" dirty="0"/>
-          </a:p>
-        </p:txBody>
-      </p:sp>
-      <p:sp>
-        <p:nvSpPr>
-          <p:cNvPr id="15" name="Shape 13"/>
-          <p:cNvSpPr/>
-          <p:nvPr/>
-        </p:nvSpPr>
-        <p:spPr>
-          <a:xfrm>
-            <a:off x="457200" y="6446520"/>
-            <a:ext cx="11277295" cy="0"/>
-          </a:xfrm>
-          <a:prstGeom prst="line">
-            <a:avLst/>
-          </a:prstGeom>
-          <a:noFill/>
-          <a:ln w="12700">
-            <a:solidFill>
-              <a:srgbClr val="D7D7D7"/>
-            </a:solidFill>
-            <a:prstDash val="solid"/>
-          </a:ln>
-        </p:spPr>
+              <a:t>I help people move into tech, engineers grow, and teams improve how they build software.</a:t>
+            </a:r>
+            <a:endParaRPr lang="en-US" sz="1600" dirty="0"/>
+          </a:p>
+        </p:txBody>
       </p:sp>
       <p:sp>
         <p:nvSpPr>
@@ -2111,31 +2396,768 @@
         </p:nvSpPr>
         <p:spPr>
           <a:xfrm>
-            <a:off x="457200" y="6473952"/>
-            <a:ext cx="3657600" cy="182880"/>
-          </a:xfrm>
-          <a:prstGeom prst="rect">
-            <a:avLst/>
-          </a:prstGeom>
-          <a:noFill/>
-          <a:ln/>
-        </p:spPr>
-        <p:txBody>
-          <a:bodyPr wrap="square" rtlCol="0" anchor="ctr"/>
+            <a:off x="804672" y="3895344"/>
+            <a:ext cx="5623560" cy="640080"/>
+          </a:xfrm>
+          <a:prstGeom prst="rect">
+            <a:avLst/>
+          </a:prstGeom>
+          <a:noFill/>
+          <a:ln/>
+        </p:spPr>
+        <p:txBody>
+          <a:bodyPr wrap="square" rtlCol="0" anchor="t"/>
           <a:lstStyle/>
           <a:p>
             <a:pPr indent="0" marL="0">
               <a:buNone/>
             </a:pPr>
             <a:r>
-              <a:rPr lang="en-US" sz="1000" dirty="0">
-                <a:solidFill>
-                  <a:srgbClr val="6B6B6B"/>
+              <a:rPr lang="en-US" sz="1600" dirty="0">
+                <a:solidFill>
+                  <a:srgbClr val="0F0F0F"/>
                 </a:solidFill>
                 <a:latin typeface="Barlow" pitchFamily="34" charset="0"/>
                 <a:ea typeface="Barlow" pitchFamily="34" charset="-122"/>
                 <a:cs typeface="Barlow" pitchFamily="34" charset="-120"/>
               </a:rPr>
+              <a:t>I am a software engineer in London working across product engineering, delivery, mentoring, and team leadership.</a:t>
+            </a:r>
+            <a:endParaRPr lang="en-US" sz="1600" dirty="0"/>
+          </a:p>
+        </p:txBody>
+      </p:sp>
+      <p:sp>
+        <p:nvSpPr>
+          <p:cNvPr id="17" name="Text 15"/>
+          <p:cNvSpPr/>
+          <p:nvPr/>
+        </p:nvSpPr>
+        <p:spPr>
+          <a:xfrm>
+            <a:off x="804672" y="4590288"/>
+            <a:ext cx="5623560" cy="749808"/>
+          </a:xfrm>
+          <a:prstGeom prst="rect">
+            <a:avLst/>
+          </a:prstGeom>
+          <a:noFill/>
+          <a:ln/>
+        </p:spPr>
+        <p:txBody>
+          <a:bodyPr wrap="square" rtlCol="0" anchor="t"/>
+          <a:lstStyle/>
+          <a:p>
+            <a:pPr indent="0" marL="0">
+              <a:buNone/>
+            </a:pPr>
+            <a:r>
+              <a:rPr lang="en-US" sz="1500" dirty="0">
+                <a:solidFill>
+                  <a:srgbClr val="6B6B6B"/>
+                </a:solidFill>
+                <a:latin typeface="Barlow" pitchFamily="34" charset="0"/>
+                <a:ea typeface="Barlow" pitchFamily="34" charset="-122"/>
+                <a:cs typeface="Barlow" pitchFamily="34" charset="-120"/>
+              </a:rPr>
+              <a:t>I focus on practical engineering improvement: clearer habits, better delivery, and more confidence for the people doing the work.</a:t>
+            </a:r>
+            <a:endParaRPr lang="en-US" sz="1500" dirty="0"/>
+          </a:p>
+        </p:txBody>
+      </p:sp>
+      <p:sp>
+        <p:nvSpPr>
+          <p:cNvPr id="18" name="Shape 16"/>
+          <p:cNvSpPr/>
+          <p:nvPr/>
+        </p:nvSpPr>
+        <p:spPr>
+          <a:xfrm>
+            <a:off x="804672" y="5532120"/>
+            <a:ext cx="1572768" cy="402336"/>
+          </a:xfrm>
+          <a:prstGeom prst="roundRect">
+            <a:avLst>
+              <a:gd name="adj" fmla="val 27273"/>
+            </a:avLst>
+          </a:prstGeom>
+          <a:solidFill>
+            <a:srgbClr val="2A7D5B">
+              <a:alpha val="14000"/>
+            </a:srgbClr>
+          </a:solidFill>
+          <a:ln w="12700">
+            <a:solidFill>
+              <a:srgbClr val="2A7D5B">
+                <a:alpha val="0"/>
+              </a:srgbClr>
+            </a:solidFill>
+            <a:prstDash val="solid"/>
+          </a:ln>
+        </p:spPr>
+      </p:sp>
+      <p:sp>
+        <p:nvSpPr>
+          <p:cNvPr id="19" name="Text 17"/>
+          <p:cNvSpPr/>
+          <p:nvPr/>
+        </p:nvSpPr>
+        <p:spPr>
+          <a:xfrm>
+            <a:off x="896112" y="5632704"/>
+            <a:ext cx="1389888" cy="164592"/>
+          </a:xfrm>
+          <a:prstGeom prst="rect">
+            <a:avLst/>
+          </a:prstGeom>
+          <a:noFill/>
+          <a:ln/>
+        </p:spPr>
+        <p:txBody>
+          <a:bodyPr wrap="square" rtlCol="0" anchor="ctr">
+            <a:normAutofit/>
+          </a:bodyPr>
+          <a:lstStyle/>
+          <a:p>
+            <a:pPr algn="ctr" indent="0" marL="0">
+              <a:buNone/>
+            </a:pPr>
+            <a:r>
+              <a:rPr lang="en-US" sz="900" b="1" dirty="0">
+                <a:solidFill>
+                  <a:srgbClr val="1B5A40"/>
+                </a:solidFill>
+                <a:latin typeface="Barlow Condensed" pitchFamily="34" charset="0"/>
+                <a:ea typeface="Barlow Condensed" pitchFamily="34" charset="-122"/>
+                <a:cs typeface="Barlow Condensed" pitchFamily="34" charset="-120"/>
+              </a:rPr>
+              <a:t>CAREER CHANGERS</a:t>
+            </a:r>
+            <a:endParaRPr lang="en-US" sz="900" dirty="0"/>
+          </a:p>
+        </p:txBody>
+      </p:sp>
+      <p:sp>
+        <p:nvSpPr>
+          <p:cNvPr id="20" name="Shape 18"/>
+          <p:cNvSpPr/>
+          <p:nvPr/>
+        </p:nvSpPr>
+        <p:spPr>
+          <a:xfrm>
+            <a:off x="2542032" y="5532120"/>
+            <a:ext cx="1901952" cy="402336"/>
+          </a:xfrm>
+          <a:prstGeom prst="roundRect">
+            <a:avLst>
+              <a:gd name="adj" fmla="val 27273"/>
+            </a:avLst>
+          </a:prstGeom>
+          <a:solidFill>
+            <a:srgbClr val="E8006A">
+              <a:alpha val="12000"/>
+            </a:srgbClr>
+          </a:solidFill>
+          <a:ln w="12700">
+            <a:solidFill>
+              <a:srgbClr val="E8006A">
+                <a:alpha val="0"/>
+              </a:srgbClr>
+            </a:solidFill>
+            <a:prstDash val="solid"/>
+          </a:ln>
+        </p:spPr>
+      </p:sp>
+      <p:sp>
+        <p:nvSpPr>
+          <p:cNvPr id="21" name="Text 19"/>
+          <p:cNvSpPr/>
+          <p:nvPr/>
+        </p:nvSpPr>
+        <p:spPr>
+          <a:xfrm>
+            <a:off x="2660904" y="5632704"/>
+            <a:ext cx="1664208" cy="164592"/>
+          </a:xfrm>
+          <a:prstGeom prst="rect">
+            <a:avLst/>
+          </a:prstGeom>
+          <a:noFill/>
+          <a:ln/>
+        </p:spPr>
+        <p:txBody>
+          <a:bodyPr wrap="square" rtlCol="0" anchor="ctr">
+            <a:normAutofit/>
+          </a:bodyPr>
+          <a:lstStyle/>
+          <a:p>
+            <a:pPr algn="ctr" indent="0" marL="0">
+              <a:buNone/>
+            </a:pPr>
+            <a:r>
+              <a:rPr lang="en-US" sz="900" b="1" dirty="0">
+                <a:solidFill>
+                  <a:srgbClr val="E8006A"/>
+                </a:solidFill>
+                <a:latin typeface="Barlow Condensed" pitchFamily="34" charset="0"/>
+                <a:ea typeface="Barlow Condensed" pitchFamily="34" charset="-122"/>
+                <a:cs typeface="Barlow Condensed" pitchFamily="34" charset="-120"/>
+              </a:rPr>
+              <a:t>ENGINEERS GROWING</a:t>
+            </a:r>
+            <a:endParaRPr lang="en-US" sz="900" dirty="0"/>
+          </a:p>
+        </p:txBody>
+      </p:sp>
+      <p:sp>
+        <p:nvSpPr>
+          <p:cNvPr id="22" name="Shape 20"/>
+          <p:cNvSpPr/>
+          <p:nvPr/>
+        </p:nvSpPr>
+        <p:spPr>
+          <a:xfrm>
+            <a:off x="4608576" y="5532120"/>
+            <a:ext cx="2148840" cy="402336"/>
+          </a:xfrm>
+          <a:prstGeom prst="roundRect">
+            <a:avLst>
+              <a:gd name="adj" fmla="val 27273"/>
+            </a:avLst>
+          </a:prstGeom>
+          <a:solidFill>
+            <a:srgbClr val="E5D8C9"/>
+          </a:solidFill>
+          <a:ln w="12700">
+            <a:solidFill>
+              <a:srgbClr val="D8C5AE"/>
+            </a:solidFill>
+            <a:prstDash val="solid"/>
+          </a:ln>
+        </p:spPr>
+      </p:sp>
+      <p:sp>
+        <p:nvSpPr>
+          <p:cNvPr id="23" name="Text 21"/>
+          <p:cNvSpPr/>
+          <p:nvPr/>
+        </p:nvSpPr>
+        <p:spPr>
+          <a:xfrm>
+            <a:off x="4736592" y="5632704"/>
+            <a:ext cx="1892808" cy="164592"/>
+          </a:xfrm>
+          <a:prstGeom prst="rect">
+            <a:avLst/>
+          </a:prstGeom>
+          <a:noFill/>
+          <a:ln/>
+        </p:spPr>
+        <p:txBody>
+          <a:bodyPr wrap="square" rtlCol="0" anchor="ctr">
+            <a:normAutofit/>
+          </a:bodyPr>
+          <a:lstStyle/>
+          <a:p>
+            <a:pPr algn="ctr" indent="0" marL="0">
+              <a:buNone/>
+            </a:pPr>
+            <a:r>
+              <a:rPr lang="en-US" sz="900" b="1" dirty="0">
+                <a:solidFill>
+                  <a:srgbClr val="0F0F0F"/>
+                </a:solidFill>
+                <a:latin typeface="Barlow Condensed" pitchFamily="34" charset="0"/>
+                <a:ea typeface="Barlow Condensed" pitchFamily="34" charset="-122"/>
+                <a:cs typeface="Barlow Condensed" pitchFamily="34" charset="-120"/>
+              </a:rPr>
+              <a:t>TEAMS RAISING THE BAR</a:t>
+            </a:r>
+            <a:endParaRPr lang="en-US" sz="900" dirty="0"/>
+          </a:p>
+        </p:txBody>
+      </p:sp>
+      <p:sp>
+        <p:nvSpPr>
+          <p:cNvPr id="24" name="Shape 22"/>
+          <p:cNvSpPr/>
+          <p:nvPr/>
+        </p:nvSpPr>
+        <p:spPr>
+          <a:xfrm>
+            <a:off x="7269480" y="2057400"/>
+            <a:ext cx="4462272" cy="1325880"/>
+          </a:xfrm>
+          <a:prstGeom prst="roundRect">
+            <a:avLst>
+              <a:gd name="adj" fmla="val 5517"/>
+            </a:avLst>
+          </a:prstGeom>
+          <a:solidFill>
+            <a:srgbClr val="101410"/>
+          </a:solidFill>
+          <a:ln w="12700">
+            <a:solidFill>
+              <a:srgbClr val="101410"/>
+            </a:solidFill>
+            <a:prstDash val="solid"/>
+          </a:ln>
+        </p:spPr>
+      </p:sp>
+      <p:sp>
+        <p:nvSpPr>
+          <p:cNvPr id="25" name="Shape 23"/>
+          <p:cNvSpPr/>
+          <p:nvPr/>
+        </p:nvSpPr>
+        <p:spPr>
+          <a:xfrm>
+            <a:off x="7269480" y="2057400"/>
+            <a:ext cx="4462272" cy="73152"/>
+          </a:xfrm>
+          <a:prstGeom prst="rect">
+            <a:avLst/>
+          </a:prstGeom>
+          <a:solidFill>
+            <a:srgbClr val="E8006A"/>
+          </a:solidFill>
+          <a:ln w="12700">
+            <a:solidFill>
+              <a:srgbClr val="E8006A"/>
+            </a:solidFill>
+            <a:prstDash val="solid"/>
+          </a:ln>
+        </p:spPr>
+      </p:sp>
+      <p:sp>
+        <p:nvSpPr>
+          <p:cNvPr id="26" name="Text 24"/>
+          <p:cNvSpPr/>
+          <p:nvPr/>
+        </p:nvSpPr>
+        <p:spPr>
+          <a:xfrm>
+            <a:off x="7516368" y="2322576"/>
+            <a:ext cx="1188720" cy="164592"/>
+          </a:xfrm>
+          <a:prstGeom prst="rect">
+            <a:avLst/>
+          </a:prstGeom>
+          <a:noFill/>
+          <a:ln/>
+        </p:spPr>
+        <p:txBody>
+          <a:bodyPr wrap="square" rtlCol="0" anchor="ctr"/>
+          <a:lstStyle/>
+          <a:p>
+            <a:pPr indent="0" marL="0">
+              <a:buNone/>
+            </a:pPr>
+            <a:r>
+              <a:rPr lang="en-US" sz="1000" b="1" dirty="0">
+                <a:solidFill>
+                  <a:srgbClr val="D8D8D8"/>
+                </a:solidFill>
+                <a:latin typeface="Barlow Condensed" pitchFamily="34" charset="0"/>
+                <a:ea typeface="Barlow Condensed" pitchFamily="34" charset="-122"/>
+                <a:cs typeface="Barlow Condensed" pitchFamily="34" charset="-120"/>
+              </a:rPr>
+              <a:t>CURRENTLY</a:t>
+            </a:r>
+            <a:endParaRPr lang="en-US" sz="1000" dirty="0"/>
+          </a:p>
+        </p:txBody>
+      </p:sp>
+      <p:sp>
+        <p:nvSpPr>
+          <p:cNvPr id="27" name="Text 25"/>
+          <p:cNvSpPr/>
+          <p:nvPr/>
+        </p:nvSpPr>
+        <p:spPr>
+          <a:xfrm>
+            <a:off x="7516368" y="2615184"/>
+            <a:ext cx="3520440" cy="310896"/>
+          </a:xfrm>
+          <a:prstGeom prst="rect">
+            <a:avLst/>
+          </a:prstGeom>
+          <a:noFill/>
+          <a:ln/>
+        </p:spPr>
+        <p:txBody>
+          <a:bodyPr wrap="square" rtlCol="0" anchor="ctr">
+            <a:normAutofit/>
+          </a:bodyPr>
+          <a:lstStyle/>
+          <a:p>
+            <a:pPr indent="0" marL="0">
+              <a:buNone/>
+            </a:pPr>
+            <a:r>
+              <a:rPr lang="en-US" sz="2300" b="1" dirty="0">
+                <a:solidFill>
+                  <a:srgbClr val="FFFFFF"/>
+                </a:solidFill>
+                <a:latin typeface="Barlow Condensed" pitchFamily="34" charset="0"/>
+                <a:ea typeface="Barlow Condensed" pitchFamily="34" charset="-122"/>
+                <a:cs typeface="Barlow Condensed" pitchFamily="34" charset="-120"/>
+              </a:rPr>
+              <a:t>Staff Engineer</a:t>
+            </a:r>
+            <a:endParaRPr lang="en-US" sz="2300" dirty="0"/>
+          </a:p>
+        </p:txBody>
+      </p:sp>
+      <p:sp>
+        <p:nvSpPr>
+          <p:cNvPr id="28" name="Text 26"/>
+          <p:cNvSpPr/>
+          <p:nvPr/>
+        </p:nvSpPr>
+        <p:spPr>
+          <a:xfrm>
+            <a:off x="7516368" y="2926080"/>
+            <a:ext cx="3520440" cy="201168"/>
+          </a:xfrm>
+          <a:prstGeom prst="rect">
+            <a:avLst/>
+          </a:prstGeom>
+          <a:noFill/>
+          <a:ln/>
+        </p:spPr>
+        <p:txBody>
+          <a:bodyPr wrap="square" rtlCol="0" anchor="ctr"/>
+          <a:lstStyle/>
+          <a:p>
+            <a:pPr indent="0" marL="0">
+              <a:buNone/>
+            </a:pPr>
+            <a:r>
+              <a:rPr lang="en-US" sz="1300" dirty="0">
+                <a:solidFill>
+                  <a:srgbClr val="D8D8D8"/>
+                </a:solidFill>
+                <a:latin typeface="Barlow" pitchFamily="34" charset="0"/>
+                <a:ea typeface="Barlow" pitchFamily="34" charset="-122"/>
+                <a:cs typeface="Barlow" pitchFamily="34" charset="-120"/>
+              </a:rPr>
+              <a:t>NewDay · London</a:t>
+            </a:r>
+            <a:endParaRPr lang="en-US" sz="1300" dirty="0"/>
+          </a:p>
+        </p:txBody>
+      </p:sp>
+      <p:sp>
+        <p:nvSpPr>
+          <p:cNvPr id="29" name="Shape 27"/>
+          <p:cNvSpPr/>
+          <p:nvPr/>
+        </p:nvSpPr>
+        <p:spPr>
+          <a:xfrm>
+            <a:off x="7269480" y="3611880"/>
+            <a:ext cx="4462272" cy="1325880"/>
+          </a:xfrm>
+          <a:prstGeom prst="roundRect">
+            <a:avLst>
+              <a:gd name="adj" fmla="val 5517"/>
+            </a:avLst>
+          </a:prstGeom>
+          <a:solidFill>
+            <a:srgbClr val="FFFAF4"/>
+          </a:solidFill>
+          <a:ln w="12700">
+            <a:solidFill>
+              <a:srgbClr val="D8C5AE"/>
+            </a:solidFill>
+            <a:prstDash val="solid"/>
+          </a:ln>
+        </p:spPr>
+      </p:sp>
+      <p:sp>
+        <p:nvSpPr>
+          <p:cNvPr id="30" name="Text 28"/>
+          <p:cNvSpPr/>
+          <p:nvPr/>
+        </p:nvSpPr>
+        <p:spPr>
+          <a:xfrm>
+            <a:off x="7516368" y="3858768"/>
+            <a:ext cx="2011680" cy="164592"/>
+          </a:xfrm>
+          <a:prstGeom prst="rect">
+            <a:avLst/>
+          </a:prstGeom>
+          <a:noFill/>
+          <a:ln/>
+        </p:spPr>
+        <p:txBody>
+          <a:bodyPr wrap="square" rtlCol="0" anchor="ctr"/>
+          <a:lstStyle/>
+          <a:p>
+            <a:pPr indent="0" marL="0">
+              <a:buNone/>
+            </a:pPr>
+            <a:r>
+              <a:rPr lang="en-US" sz="1000" b="1" dirty="0">
+                <a:solidFill>
+                  <a:srgbClr val="1B5A40"/>
+                </a:solidFill>
+                <a:latin typeface="Barlow Condensed" pitchFamily="34" charset="0"/>
+                <a:ea typeface="Barlow Condensed" pitchFamily="34" charset="-122"/>
+                <a:cs typeface="Barlow Condensed" pitchFamily="34" charset="-120"/>
+              </a:rPr>
+              <a:t>TEACHING BACKGROUND</a:t>
+            </a:r>
+            <a:endParaRPr lang="en-US" sz="1000" dirty="0"/>
+          </a:p>
+        </p:txBody>
+      </p:sp>
+      <p:sp>
+        <p:nvSpPr>
+          <p:cNvPr id="31" name="Text 29"/>
+          <p:cNvSpPr/>
+          <p:nvPr/>
+        </p:nvSpPr>
+        <p:spPr>
+          <a:xfrm>
+            <a:off x="7516368" y="4142232"/>
+            <a:ext cx="3794760" cy="329184"/>
+          </a:xfrm>
+          <a:prstGeom prst="rect">
+            <a:avLst/>
+          </a:prstGeom>
+          <a:noFill/>
+          <a:ln/>
+        </p:spPr>
+        <p:txBody>
+          <a:bodyPr wrap="square" rtlCol="0" anchor="ctr">
+            <a:normAutofit/>
+          </a:bodyPr>
+          <a:lstStyle/>
+          <a:p>
+            <a:pPr indent="0" marL="0">
+              <a:buNone/>
+            </a:pPr>
+            <a:r>
+              <a:rPr lang="en-US" sz="1700" b="1" dirty="0">
+                <a:solidFill>
+                  <a:srgbClr val="0F0F0F"/>
+                </a:solidFill>
+                <a:latin typeface="Barlow Condensed" pitchFamily="34" charset="0"/>
+                <a:ea typeface="Barlow Condensed" pitchFamily="34" charset="-122"/>
+                <a:cs typeface="Barlow Condensed" pitchFamily="34" charset="-120"/>
+              </a:rPr>
+              <a:t>Full-Stack Bootcamp Instructor</a:t>
+            </a:r>
+            <a:endParaRPr lang="en-US" sz="1700" dirty="0"/>
+          </a:p>
+        </p:txBody>
+      </p:sp>
+      <p:sp>
+        <p:nvSpPr>
+          <p:cNvPr id="32" name="Text 30"/>
+          <p:cNvSpPr/>
+          <p:nvPr/>
+        </p:nvSpPr>
+        <p:spPr>
+          <a:xfrm>
+            <a:off x="7516368" y="4498848"/>
+            <a:ext cx="3566160" cy="201168"/>
+          </a:xfrm>
+          <a:prstGeom prst="rect">
+            <a:avLst/>
+          </a:prstGeom>
+          <a:noFill/>
+          <a:ln/>
+        </p:spPr>
+        <p:txBody>
+          <a:bodyPr wrap="square" rtlCol="0" anchor="ctr"/>
+          <a:lstStyle/>
+          <a:p>
+            <a:pPr indent="0" marL="0">
+              <a:buNone/>
+            </a:pPr>
+            <a:r>
+              <a:rPr lang="en-US" sz="1300" dirty="0">
+                <a:solidFill>
+                  <a:srgbClr val="6B6B6B"/>
+                </a:solidFill>
+                <a:latin typeface="Barlow" pitchFamily="34" charset="0"/>
+                <a:ea typeface="Barlow" pitchFamily="34" charset="-122"/>
+                <a:cs typeface="Barlow" pitchFamily="34" charset="-120"/>
+              </a:rPr>
+              <a:t>The Jump Digital School</a:t>
+            </a:r>
+            <a:endParaRPr lang="en-US" sz="1300" dirty="0"/>
+          </a:p>
+        </p:txBody>
+      </p:sp>
+      <p:sp>
+        <p:nvSpPr>
+          <p:cNvPr id="33" name="Shape 31"/>
+          <p:cNvSpPr/>
+          <p:nvPr/>
+        </p:nvSpPr>
+        <p:spPr>
+          <a:xfrm>
+            <a:off x="7269480" y="5166360"/>
+            <a:ext cx="4462272" cy="1051560"/>
+          </a:xfrm>
+          <a:prstGeom prst="roundRect">
+            <a:avLst>
+              <a:gd name="adj" fmla="val 6957"/>
+            </a:avLst>
+          </a:prstGeom>
+          <a:solidFill>
+            <a:srgbClr val="F6ECE1"/>
+          </a:solidFill>
+          <a:ln w="12700">
+            <a:solidFill>
+              <a:srgbClr val="D8C5AE"/>
+            </a:solidFill>
+            <a:prstDash val="solid"/>
+          </a:ln>
+        </p:spPr>
+      </p:sp>
+      <p:sp>
+        <p:nvSpPr>
+          <p:cNvPr id="34" name="Text 32"/>
+          <p:cNvSpPr/>
+          <p:nvPr/>
+        </p:nvSpPr>
+        <p:spPr>
+          <a:xfrm>
+            <a:off x="7516368" y="5413248"/>
+            <a:ext cx="1280160" cy="164592"/>
+          </a:xfrm>
+          <a:prstGeom prst="rect">
+            <a:avLst/>
+          </a:prstGeom>
+          <a:noFill/>
+          <a:ln/>
+        </p:spPr>
+        <p:txBody>
+          <a:bodyPr wrap="square" rtlCol="0" anchor="ctr"/>
+          <a:lstStyle/>
+          <a:p>
+            <a:pPr indent="0" marL="0">
+              <a:buNone/>
+            </a:pPr>
+            <a:r>
+              <a:rPr lang="en-US" sz="1000" b="1" dirty="0">
+                <a:solidFill>
+                  <a:srgbClr val="1B5A40"/>
+                </a:solidFill>
+                <a:latin typeface="Barlow Condensed" pitchFamily="34" charset="0"/>
+                <a:ea typeface="Barlow Condensed" pitchFamily="34" charset="-122"/>
+                <a:cs typeface="Barlow Condensed" pitchFamily="34" charset="-120"/>
+              </a:rPr>
+              <a:t>QUICK FACTS</a:t>
+            </a:r>
+            <a:endParaRPr lang="en-US" sz="1000" dirty="0"/>
+          </a:p>
+        </p:txBody>
+      </p:sp>
+      <p:sp>
+        <p:nvSpPr>
+          <p:cNvPr id="35" name="Text 33"/>
+          <p:cNvSpPr/>
+          <p:nvPr/>
+        </p:nvSpPr>
+        <p:spPr>
+          <a:xfrm>
+            <a:off x="7516368" y="5669280"/>
+            <a:ext cx="3749040" cy="274320"/>
+          </a:xfrm>
+          <a:prstGeom prst="rect">
+            <a:avLst/>
+          </a:prstGeom>
+          <a:noFill/>
+          <a:ln/>
+        </p:spPr>
+        <p:txBody>
+          <a:bodyPr wrap="square" rtlCol="0" anchor="ctr">
+            <a:normAutofit/>
+          </a:bodyPr>
+          <a:lstStyle/>
+          <a:p>
+            <a:pPr indent="0" marL="0">
+              <a:buNone/>
+            </a:pPr>
+            <a:r>
+              <a:rPr lang="en-US" sz="1400" dirty="0">
+                <a:solidFill>
+                  <a:srgbClr val="0F0F0F"/>
+                </a:solidFill>
+                <a:latin typeface="Barlow" pitchFamily="34" charset="0"/>
+                <a:ea typeface="Barlow" pitchFamily="34" charset="-122"/>
+                <a:cs typeface="Barlow" pitchFamily="34" charset="-120"/>
+              </a:rPr>
+              <a:t>Fintech · mentoring · engineering practice</a:t>
+            </a:r>
+            <a:endParaRPr lang="en-US" sz="1400" dirty="0"/>
+          </a:p>
+        </p:txBody>
+      </p:sp>
+      <p:sp>
+        <p:nvSpPr>
+          <p:cNvPr id="36" name="Shape 34"/>
+          <p:cNvSpPr/>
+          <p:nvPr/>
+        </p:nvSpPr>
+        <p:spPr>
+          <a:xfrm>
+            <a:off x="457200" y="6446520"/>
+            <a:ext cx="11277295" cy="0"/>
+          </a:xfrm>
+          <a:prstGeom prst="line">
+            <a:avLst/>
+          </a:prstGeom>
+          <a:noFill/>
+          <a:ln w="12700">
+            <a:solidFill>
+              <a:srgbClr val="D7D7D7"/>
+            </a:solidFill>
+            <a:prstDash val="solid"/>
+          </a:ln>
+        </p:spPr>
+      </p:sp>
+      <p:sp>
+        <p:nvSpPr>
+          <p:cNvPr id="37" name="Text 35"/>
+          <p:cNvSpPr/>
+          <p:nvPr/>
+        </p:nvSpPr>
+        <p:spPr>
+          <a:xfrm>
+            <a:off x="457200" y="6473952"/>
+            <a:ext cx="3657600" cy="182880"/>
+          </a:xfrm>
+          <a:prstGeom prst="rect">
+            <a:avLst/>
+          </a:prstGeom>
+          <a:noFill/>
+          <a:ln/>
+        </p:spPr>
+        <p:txBody>
+          <a:bodyPr wrap="square" rtlCol="0" anchor="ctr"/>
+          <a:lstStyle/>
+          <a:p>
+            <a:pPr indent="0" marL="0">
+              <a:buNone/>
+            </a:pPr>
+            <a:r>
+              <a:rPr lang="en-US" sz="1000" dirty="0">
+                <a:solidFill>
+                  <a:srgbClr val="6B6B6B"/>
+                </a:solidFill>
+                <a:latin typeface="Barlow" pitchFamily="34" charset="0"/>
+                <a:ea typeface="Barlow" pitchFamily="34" charset="-122"/>
+                <a:cs typeface="Barlow" pitchFamily="34" charset="-120"/>
+              </a:rPr>
               <a:t>sourcier.uk</a:t>
             </a:r>
             <a:endParaRPr lang="en-US" sz="1000" dirty="0"/>
@@ -2144,7 +3166,7 @@
       </p:sp>
       <p:sp>
         <p:nvSpPr>
-          <p:cNvPr id="17" name="Text 15"/>
+          <p:cNvPr id="38" name="Text 36"/>
           <p:cNvSpPr/>
           <p:nvPr/>
         </p:nvSpPr>
@@ -2453,7 +3475,7 @@
                 <a:ea typeface="Barlow Condensed" pitchFamily="34" charset="-122"/>
                 <a:cs typeface="Barlow Condensed" pitchFamily="34" charset="-120"/>
               </a:rPr>
-              <a:t>CONTENT LAYOUT</a:t>
+              <a:t>SECTION HEADING</a:t>
             </a:r>
             <a:endParaRPr lang="en-US" sz="3400" dirty="0"/>
           </a:p>
@@ -2492,7 +3514,7 @@
                 <a:ea typeface="Barlow" pitchFamily="34" charset="-122"/>
                 <a:cs typeface="Barlow" pitchFamily="34" charset="-120"/>
               </a:rPr>
-              <a:t>Two-column slide with clear visual hierarchy.</a:t>
+              <a:t>Use this slide to split major themes.</a:t>
             </a:r>
             <a:endParaRPr lang="en-US" sz="1800" dirty="0"/>
           </a:p>
@@ -2506,11 +3528,83 @@
         </p:nvSpPr>
         <p:spPr>
           <a:xfrm>
-            <a:off x="457200" y="2148840"/>
-            <a:ext cx="5440680" cy="3977640"/>
-          </a:xfrm>
-          <a:prstGeom prst="rect">
-            <a:avLst/>
+            <a:off x="457200" y="1892808"/>
+            <a:ext cx="1645920" cy="256032"/>
+          </a:xfrm>
+          <a:prstGeom prst="roundRect">
+            <a:avLst>
+              <a:gd name="adj" fmla="val 50000"/>
+            </a:avLst>
+          </a:prstGeom>
+          <a:solidFill>
+            <a:srgbClr val="2A7D5B">
+              <a:alpha val="18000"/>
+            </a:srgbClr>
+          </a:solidFill>
+          <a:ln w="12700">
+            <a:solidFill>
+              <a:srgbClr val="2A7D5B">
+                <a:alpha val="0"/>
+              </a:srgbClr>
+            </a:solidFill>
+            <a:prstDash val="solid"/>
+          </a:ln>
+        </p:spPr>
+      </p:sp>
+      <p:sp>
+        <p:nvSpPr>
+          <p:cNvPr id="12" name="Text 10"/>
+          <p:cNvSpPr/>
+          <p:nvPr/>
+        </p:nvSpPr>
+        <p:spPr>
+          <a:xfrm>
+            <a:off x="621792" y="1929384"/>
+            <a:ext cx="1325880" cy="182880"/>
+          </a:xfrm>
+          <a:prstGeom prst="rect">
+            <a:avLst/>
+          </a:prstGeom>
+          <a:noFill/>
+          <a:ln/>
+        </p:spPr>
+        <p:txBody>
+          <a:bodyPr wrap="square" rtlCol="0" anchor="ctr"/>
+          <a:lstStyle/>
+          <a:p>
+            <a:pPr indent="0" marL="0">
+              <a:buNone/>
+            </a:pPr>
+            <a:r>
+              <a:rPr lang="en-US" sz="1000" b="1" dirty="0">
+                <a:solidFill>
+                  <a:srgbClr val="1B5A40"/>
+                </a:solidFill>
+                <a:latin typeface="Barlow Condensed" pitchFamily="34" charset="0"/>
+                <a:ea typeface="Barlow Condensed" pitchFamily="34" charset="-122"/>
+                <a:cs typeface="Barlow Condensed" pitchFamily="34" charset="-120"/>
+              </a:rPr>
+              <a:t>GUIDE BREAK</a:t>
+            </a:r>
+            <a:endParaRPr lang="en-US" sz="1000" dirty="0"/>
+          </a:p>
+        </p:txBody>
+      </p:sp>
+      <p:sp>
+        <p:nvSpPr>
+          <p:cNvPr id="13" name="Shape 11"/>
+          <p:cNvSpPr/>
+          <p:nvPr/>
+        </p:nvSpPr>
+        <p:spPr>
+          <a:xfrm>
+            <a:off x="457200" y="2331720"/>
+            <a:ext cx="11277295" cy="3246120"/>
+          </a:xfrm>
+          <a:prstGeom prst="roundRect">
+            <a:avLst>
+              <a:gd name="adj" fmla="val 2254"/>
+            </a:avLst>
           </a:prstGeom>
           <a:solidFill>
             <a:srgbClr val="FFFAF4"/>
@@ -2525,39 +3619,39 @@
       </p:sp>
       <p:sp>
         <p:nvSpPr>
-          <p:cNvPr id="12" name="Shape 10"/>
-          <p:cNvSpPr/>
-          <p:nvPr/>
-        </p:nvSpPr>
-        <p:spPr>
-          <a:xfrm>
-            <a:off x="6291072" y="2148840"/>
-            <a:ext cx="5440680" cy="3977640"/>
+          <p:cNvPr id="14" name="Shape 12"/>
+          <p:cNvSpPr/>
+          <p:nvPr/>
+        </p:nvSpPr>
+        <p:spPr>
+          <a:xfrm>
+            <a:off x="457200" y="2331720"/>
+            <a:ext cx="146304" cy="3246120"/>
           </a:xfrm>
           <a:prstGeom prst="rect">
             <a:avLst/>
           </a:prstGeom>
           <a:solidFill>
-            <a:srgbClr val="FFFAF4"/>
+            <a:srgbClr val="E8006A"/>
           </a:solidFill>
           <a:ln w="12700">
             <a:solidFill>
-              <a:srgbClr val="D8C5AE"/>
-            </a:solidFill>
-            <a:prstDash val="solid"/>
-          </a:ln>
-        </p:spPr>
-      </p:sp>
-      <p:sp>
-        <p:nvSpPr>
-          <p:cNvPr id="13" name="Text 11"/>
-          <p:cNvSpPr/>
-          <p:nvPr/>
-        </p:nvSpPr>
-        <p:spPr>
-          <a:xfrm>
-            <a:off x="786384" y="2487168"/>
-            <a:ext cx="4754880" cy="347472"/>
+              <a:srgbClr val="E8006A"/>
+            </a:solidFill>
+            <a:prstDash val="solid"/>
+          </a:ln>
+        </p:spPr>
+      </p:sp>
+      <p:sp>
+        <p:nvSpPr>
+          <p:cNvPr id="15" name="Text 13"/>
+          <p:cNvSpPr/>
+          <p:nvPr/>
+        </p:nvSpPr>
+        <p:spPr>
+          <a:xfrm>
+            <a:off x="960120" y="3063240"/>
+            <a:ext cx="8961120" cy="658368"/>
           </a:xfrm>
           <a:prstGeom prst="rect">
             <a:avLst/>
@@ -2573,7 +3667,7 @@
               <a:buNone/>
             </a:pPr>
             <a:r>
-              <a:rPr lang="en-US" sz="2400" b="1" dirty="0">
+              <a:rPr lang="en-US" sz="4200" b="1" dirty="0">
                 <a:solidFill>
                   <a:srgbClr val="0F0F0F"/>
                 </a:solidFill>
@@ -2581,255 +3675,116 @@
                 <a:ea typeface="Barlow Condensed" pitchFamily="34" charset="-122"/>
                 <a:cs typeface="Barlow Condensed" pitchFamily="34" charset="-120"/>
               </a:rPr>
-              <a:t>Left column heading</a:t>
-            </a:r>
-            <a:endParaRPr lang="en-US" sz="2400" dirty="0"/>
-          </a:p>
-        </p:txBody>
-      </p:sp>
-      <p:sp>
-        <p:nvSpPr>
-          <p:cNvPr id="14" name="Text 12"/>
-          <p:cNvSpPr/>
-          <p:nvPr/>
-        </p:nvSpPr>
-        <p:spPr>
-          <a:xfrm>
-            <a:off x="786384" y="2971800"/>
-            <a:ext cx="4754880" cy="2834640"/>
-          </a:xfrm>
-          <a:prstGeom prst="rect">
-            <a:avLst/>
-          </a:prstGeom>
-          <a:noFill/>
-          <a:ln/>
-        </p:spPr>
-        <p:txBody>
-          <a:bodyPr wrap="square" rtlCol="0" anchor="t"/>
+              <a:t>SECTION TITLE</a:t>
+            </a:r>
+            <a:endParaRPr lang="en-US" sz="4200" dirty="0"/>
+          </a:p>
+        </p:txBody>
+      </p:sp>
+      <p:sp>
+        <p:nvSpPr>
+          <p:cNvPr id="16" name="Text 14"/>
+          <p:cNvSpPr/>
+          <p:nvPr/>
+        </p:nvSpPr>
+        <p:spPr>
+          <a:xfrm>
+            <a:off x="960120" y="3840480"/>
+            <a:ext cx="9601200" cy="365760"/>
+          </a:xfrm>
+          <a:prstGeom prst="rect">
+            <a:avLst/>
+          </a:prstGeom>
+          <a:noFill/>
+          <a:ln/>
+        </p:spPr>
+        <p:txBody>
+          <a:bodyPr wrap="square" rtlCol="0" anchor="ctr"/>
           <a:lstStyle/>
           <a:p>
             <a:pPr indent="0" marL="0">
               <a:buNone/>
             </a:pPr>
             <a:r>
-              <a:rPr lang="en-US" sz="1700" dirty="0">
-                <a:solidFill>
-                  <a:srgbClr val="0F0F0F"/>
+              <a:rPr lang="en-US" sz="1800" dirty="0">
+                <a:solidFill>
+                  <a:srgbClr val="6B6B6B"/>
                 </a:solidFill>
                 <a:latin typeface="Barlow" pitchFamily="34" charset="0"/>
                 <a:ea typeface="Barlow" pitchFamily="34" charset="-122"/>
                 <a:cs typeface="Barlow" pitchFamily="34" charset="-120"/>
               </a:rPr>
-              <a:t>- Point one</a:t>
-            </a:r>
-            <a:endParaRPr lang="en-US" sz="1700" dirty="0"/>
-          </a:p>
+              <a:t>Optional context line for this part of the deck</a:t>
+            </a:r>
+            <a:endParaRPr lang="en-US" sz="1800" dirty="0"/>
+          </a:p>
+        </p:txBody>
+      </p:sp>
+      <p:sp>
+        <p:nvSpPr>
+          <p:cNvPr id="17" name="Shape 15"/>
+          <p:cNvSpPr/>
+          <p:nvPr/>
+        </p:nvSpPr>
+        <p:spPr>
+          <a:xfrm>
+            <a:off x="457200" y="6446520"/>
+            <a:ext cx="11277295" cy="0"/>
+          </a:xfrm>
+          <a:prstGeom prst="line">
+            <a:avLst/>
+          </a:prstGeom>
+          <a:noFill/>
+          <a:ln w="12700">
+            <a:solidFill>
+              <a:srgbClr val="D7D7D7"/>
+            </a:solidFill>
+            <a:prstDash val="solid"/>
+          </a:ln>
+        </p:spPr>
+      </p:sp>
+      <p:sp>
+        <p:nvSpPr>
+          <p:cNvPr id="18" name="Text 16"/>
+          <p:cNvSpPr/>
+          <p:nvPr/>
+        </p:nvSpPr>
+        <p:spPr>
+          <a:xfrm>
+            <a:off x="457200" y="6473952"/>
+            <a:ext cx="3657600" cy="182880"/>
+          </a:xfrm>
+          <a:prstGeom prst="rect">
+            <a:avLst/>
+          </a:prstGeom>
+          <a:noFill/>
+          <a:ln/>
+        </p:spPr>
+        <p:txBody>
+          <a:bodyPr wrap="square" rtlCol="0" anchor="ctr"/>
+          <a:lstStyle/>
           <a:p>
             <a:pPr indent="0" marL="0">
               <a:buNone/>
             </a:pPr>
             <a:r>
-              <a:rPr lang="en-US" sz="1700" dirty="0">
-                <a:solidFill>
-                  <a:srgbClr val="0F0F0F"/>
+              <a:rPr lang="en-US" sz="1000" dirty="0">
+                <a:solidFill>
+                  <a:srgbClr val="6B6B6B"/>
                 </a:solidFill>
                 <a:latin typeface="Barlow" pitchFamily="34" charset="0"/>
                 <a:ea typeface="Barlow" pitchFamily="34" charset="-122"/>
                 <a:cs typeface="Barlow" pitchFamily="34" charset="-120"/>
               </a:rPr>
-              <a:t>- Point two</a:t>
-            </a:r>
-            <a:endParaRPr lang="en-US" sz="1700" dirty="0"/>
-          </a:p>
-          <a:p>
-            <a:pPr indent="0" marL="0">
-              <a:buNone/>
-            </a:pPr>
-            <a:r>
-              <a:rPr lang="en-US" sz="1700" dirty="0">
-                <a:solidFill>
-                  <a:srgbClr val="0F0F0F"/>
-                </a:solidFill>
-                <a:latin typeface="Barlow" pitchFamily="34" charset="0"/>
-                <a:ea typeface="Barlow" pitchFamily="34" charset="-122"/>
-                <a:cs typeface="Barlow" pitchFamily="34" charset="-120"/>
-              </a:rPr>
-              <a:t>- Point three</a:t>
-            </a:r>
-            <a:endParaRPr lang="en-US" sz="1700" dirty="0"/>
-          </a:p>
-        </p:txBody>
-      </p:sp>
-      <p:sp>
-        <p:nvSpPr>
-          <p:cNvPr id="15" name="Text 13"/>
-          <p:cNvSpPr/>
-          <p:nvPr/>
-        </p:nvSpPr>
-        <p:spPr>
-          <a:xfrm>
-            <a:off x="6620256" y="2487168"/>
-            <a:ext cx="4754880" cy="347472"/>
-          </a:xfrm>
-          <a:prstGeom prst="rect">
-            <a:avLst/>
-          </a:prstGeom>
-          <a:noFill/>
-          <a:ln/>
-        </p:spPr>
-        <p:txBody>
-          <a:bodyPr wrap="square" rtlCol="0" anchor="ctr"/>
-          <a:lstStyle/>
-          <a:p>
-            <a:pPr indent="0" marL="0">
-              <a:buNone/>
-            </a:pPr>
-            <a:r>
-              <a:rPr lang="en-US" sz="2400" b="1" dirty="0">
-                <a:solidFill>
-                  <a:srgbClr val="0F0F0F"/>
-                </a:solidFill>
-                <a:latin typeface="Barlow Condensed" pitchFamily="34" charset="0"/>
-                <a:ea typeface="Barlow Condensed" pitchFamily="34" charset="-122"/>
-                <a:cs typeface="Barlow Condensed" pitchFamily="34" charset="-120"/>
-              </a:rPr>
-              <a:t>Right column heading</a:t>
-            </a:r>
-            <a:endParaRPr lang="en-US" sz="2400" dirty="0"/>
-          </a:p>
-        </p:txBody>
-      </p:sp>
-      <p:sp>
-        <p:nvSpPr>
-          <p:cNvPr id="16" name="Shape 14"/>
-          <p:cNvSpPr/>
-          <p:nvPr/>
-        </p:nvSpPr>
-        <p:spPr>
-          <a:xfrm>
-            <a:off x="6620256" y="2971800"/>
-            <a:ext cx="4754880" cy="2834640"/>
-          </a:xfrm>
-          <a:prstGeom prst="roundRect">
-            <a:avLst>
-              <a:gd name="adj" fmla="val 2581"/>
-            </a:avLst>
-          </a:prstGeom>
-          <a:solidFill>
-            <a:srgbClr val="F6ECE1"/>
-          </a:solidFill>
-          <a:ln w="12700">
-            <a:solidFill>
-              <a:srgbClr val="D8C5AE"/>
-            </a:solidFill>
-            <a:prstDash val="solid"/>
-          </a:ln>
-        </p:spPr>
-      </p:sp>
-      <p:sp>
-        <p:nvSpPr>
-          <p:cNvPr id="17" name="Text 15"/>
-          <p:cNvSpPr/>
-          <p:nvPr/>
-        </p:nvSpPr>
-        <p:spPr>
-          <a:xfrm>
-            <a:off x="6858000" y="4160520"/>
-            <a:ext cx="4297680" cy="320040"/>
-          </a:xfrm>
-          <a:prstGeom prst="rect">
-            <a:avLst/>
-          </a:prstGeom>
-          <a:noFill/>
-          <a:ln/>
-        </p:spPr>
-        <p:txBody>
-          <a:bodyPr wrap="square" rtlCol="0" anchor="ctr"/>
-          <a:lstStyle/>
-          <a:p>
-            <a:pPr algn="ctr" indent="0" marL="0">
-              <a:buNone/>
-            </a:pPr>
-            <a:r>
-              <a:rPr lang="en-US" sz="1400" dirty="0">
-                <a:solidFill>
-                  <a:srgbClr val="6B6B6B"/>
-                </a:solidFill>
-                <a:latin typeface="Barlow" pitchFamily="34" charset="0"/>
-                <a:ea typeface="Barlow" pitchFamily="34" charset="-122"/>
-                <a:cs typeface="Barlow" pitchFamily="34" charset="-120"/>
-              </a:rPr>
-              <a:t>Drop chart, screenshot, or code image here</a:t>
-            </a:r>
-            <a:endParaRPr lang="en-US" sz="1400" dirty="0"/>
-          </a:p>
-        </p:txBody>
-      </p:sp>
-      <p:sp>
-        <p:nvSpPr>
-          <p:cNvPr id="18" name="Shape 16"/>
-          <p:cNvSpPr/>
-          <p:nvPr/>
-        </p:nvSpPr>
-        <p:spPr>
-          <a:xfrm>
-            <a:off x="457200" y="6446520"/>
-            <a:ext cx="11277295" cy="0"/>
-          </a:xfrm>
-          <a:prstGeom prst="line">
-            <a:avLst/>
-          </a:prstGeom>
-          <a:noFill/>
-          <a:ln w="12700">
-            <a:solidFill>
-              <a:srgbClr val="D7D7D7"/>
-            </a:solidFill>
-            <a:prstDash val="solid"/>
-          </a:ln>
-        </p:spPr>
+              <a:t>sourcier.uk</a:t>
+            </a:r>
+            <a:endParaRPr lang="en-US" sz="1000" dirty="0"/>
+          </a:p>
+        </p:txBody>
       </p:sp>
       <p:sp>
         <p:nvSpPr>
           <p:cNvPr id="19" name="Text 17"/>
-          <p:cNvSpPr/>
-          <p:nvPr/>
-        </p:nvSpPr>
-        <p:spPr>
-          <a:xfrm>
-            <a:off x="457200" y="6473952"/>
-            <a:ext cx="3657600" cy="182880"/>
-          </a:xfrm>
-          <a:prstGeom prst="rect">
-            <a:avLst/>
-          </a:prstGeom>
-          <a:noFill/>
-          <a:ln/>
-        </p:spPr>
-        <p:txBody>
-          <a:bodyPr wrap="square" rtlCol="0" anchor="ctr"/>
-          <a:lstStyle/>
-          <a:p>
-            <a:pPr indent="0" marL="0">
-              <a:buNone/>
-            </a:pPr>
-            <a:r>
-              <a:rPr lang="en-US" sz="1000" dirty="0">
-                <a:solidFill>
-                  <a:srgbClr val="6B6B6B"/>
-                </a:solidFill>
-                <a:latin typeface="Barlow" pitchFamily="34" charset="0"/>
-                <a:ea typeface="Barlow" pitchFamily="34" charset="-122"/>
-                <a:cs typeface="Barlow" pitchFamily="34" charset="-120"/>
-              </a:rPr>
-              <a:t>sourcier.uk</a:t>
-            </a:r>
-            <a:endParaRPr lang="en-US" sz="1000" dirty="0"/>
-          </a:p>
-        </p:txBody>
-      </p:sp>
-      <p:sp>
-        <p:nvSpPr>
-          <p:cNvPr id="20" name="Text 18"/>
           <p:cNvSpPr/>
           <p:nvPr/>
         </p:nvSpPr>
@@ -3138,7 +4093,7 @@
                 <a:ea typeface="Barlow Condensed" pitchFamily="34" charset="-122"/>
                 <a:cs typeface="Barlow Condensed" pitchFamily="34" charset="-120"/>
               </a:rPr>
-              <a:t>QUOTE LAYOUT</a:t>
+              <a:t>GUIDE MAP</a:t>
             </a:r>
             <a:endParaRPr lang="en-US" sz="3400" dirty="0"/>
           </a:p>
@@ -3177,7 +4132,7 @@
                 <a:ea typeface="Barlow" pitchFamily="34" charset="-122"/>
                 <a:cs typeface="Barlow" pitchFamily="34" charset="-120"/>
               </a:rPr>
-              <a:t>Ideal for key takeaways and narrative pivots.</a:t>
+              <a:t>A fast orientation slide for what to cover next.</a:t>
             </a:r>
             <a:endParaRPr lang="en-US" sz="1800" dirty="0"/>
           </a:p>
@@ -3191,12 +4146,12 @@
         </p:nvSpPr>
         <p:spPr>
           <a:xfrm>
-            <a:off x="1143000" y="2240280"/>
-            <a:ext cx="9921240" cy="3063240"/>
+            <a:off x="457200" y="2057400"/>
+            <a:ext cx="11277295" cy="4206240"/>
           </a:xfrm>
           <a:prstGeom prst="roundRect">
             <a:avLst>
-              <a:gd name="adj" fmla="val 2985"/>
+              <a:gd name="adj" fmla="val 2174"/>
             </a:avLst>
           </a:prstGeom>
           <a:solidFill>
@@ -3204,7 +4159,7 @@
           </a:solidFill>
           <a:ln w="12700">
             <a:solidFill>
-              <a:srgbClr val="E8006A"/>
+              <a:srgbClr val="D8C5AE"/>
             </a:solidFill>
             <a:prstDash val="solid"/>
           </a:ln>
@@ -3218,18 +4173,16 @@
         </p:nvSpPr>
         <p:spPr>
           <a:xfrm>
-            <a:off x="1143000" y="2240280"/>
-            <a:ext cx="128016" cy="3063240"/>
-          </a:xfrm>
-          <a:prstGeom prst="rect">
-            <a:avLst/>
-          </a:prstGeom>
-          <a:solidFill>
-            <a:srgbClr val="2A7D5B"/>
-          </a:solidFill>
-          <a:ln w="12700">
-            <a:solidFill>
-              <a:srgbClr val="2A7D5B"/>
+            <a:off x="822960" y="2651760"/>
+            <a:ext cx="10561320" cy="0"/>
+          </a:xfrm>
+          <a:prstGeom prst="line">
+            <a:avLst/>
+          </a:prstGeom>
+          <a:noFill/>
+          <a:ln w="12700">
+            <a:solidFill>
+              <a:srgbClr val="D8C5AE"/>
             </a:solidFill>
             <a:prstDash val="solid"/>
           </a:ln>
@@ -3243,8 +4196,8 @@
         </p:nvSpPr>
         <p:spPr>
           <a:xfrm>
-            <a:off x="1554480" y="2468880"/>
-            <a:ext cx="822960" cy="640080"/>
+            <a:off x="868680" y="2286000"/>
+            <a:ext cx="3840480" cy="274320"/>
           </a:xfrm>
           <a:prstGeom prst="rect">
             <a:avLst/>
@@ -3260,56 +4213,264 @@
               <a:buNone/>
             </a:pPr>
             <a:r>
-              <a:rPr lang="en-US" sz="7200" dirty="0">
-                <a:solidFill>
-                  <a:srgbClr val="E8006A"/>
+              <a:rPr lang="en-US" sz="1400" b="1" dirty="0">
+                <a:solidFill>
+                  <a:srgbClr val="1B5A40"/>
                 </a:solidFill>
                 <a:latin typeface="Barlow Condensed" pitchFamily="34" charset="0"/>
                 <a:ea typeface="Barlow Condensed" pitchFamily="34" charset="-122"/>
                 <a:cs typeface="Barlow Condensed" pitchFamily="34" charset="-120"/>
               </a:rPr>
-              <a:t>"</a:t>
-            </a:r>
-            <a:endParaRPr lang="en-US" sz="7200" dirty="0"/>
-          </a:p>
-        </p:txBody>
-      </p:sp>
-      <p:sp>
-        <p:nvSpPr>
-          <p:cNvPr id="14" name="Text 12"/>
-          <p:cNvSpPr/>
-          <p:nvPr/>
-        </p:nvSpPr>
-        <p:spPr>
-          <a:xfrm>
-            <a:off x="2194560" y="3017520"/>
-            <a:ext cx="8138160" cy="1280160"/>
-          </a:xfrm>
-          <a:prstGeom prst="rect">
-            <a:avLst/>
-          </a:prstGeom>
-          <a:noFill/>
-          <a:ln/>
-        </p:spPr>
-        <p:txBody>
-          <a:bodyPr wrap="square" rtlCol="0" anchor="ctr">
-            <a:normAutofit/>
-          </a:bodyPr>
-          <a:lstStyle/>
-          <a:p>
-            <a:pPr algn="ctr" indent="0" marL="0">
-              <a:buNone/>
-            </a:pPr>
-            <a:r>
-              <a:rPr lang="en-US" sz="2700" i="1" dirty="0">
+              <a:t>WHERE WE'RE GOING</a:t>
+            </a:r>
+            <a:endParaRPr lang="en-US" sz="1400" dirty="0"/>
+          </a:p>
+        </p:txBody>
+      </p:sp>
+      <p:sp>
+        <p:nvSpPr>
+          <p:cNvPr id="14" name="Shape 12"/>
+          <p:cNvSpPr/>
+          <p:nvPr/>
+        </p:nvSpPr>
+        <p:spPr>
+          <a:xfrm>
+            <a:off x="868680" y="2971800"/>
+            <a:ext cx="3383280" cy="2697480"/>
+          </a:xfrm>
+          <a:prstGeom prst="roundRect">
+            <a:avLst>
+              <a:gd name="adj" fmla="val 2712"/>
+            </a:avLst>
+          </a:prstGeom>
+          <a:solidFill>
+            <a:srgbClr val="F6ECE1"/>
+          </a:solidFill>
+          <a:ln w="12700">
+            <a:solidFill>
+              <a:srgbClr val="D8C5AE"/>
+            </a:solidFill>
+            <a:prstDash val="solid"/>
+          </a:ln>
+        </p:spPr>
+      </p:sp>
+      <p:sp>
+        <p:nvSpPr>
+          <p:cNvPr id="15" name="Text 13"/>
+          <p:cNvSpPr/>
+          <p:nvPr/>
+        </p:nvSpPr>
+        <p:spPr>
+          <a:xfrm>
+            <a:off x="1115568" y="3154680"/>
+            <a:ext cx="548640" cy="237744"/>
+          </a:xfrm>
+          <a:prstGeom prst="rect">
+            <a:avLst/>
+          </a:prstGeom>
+          <a:noFill/>
+          <a:ln/>
+        </p:spPr>
+        <p:txBody>
+          <a:bodyPr wrap="square" rtlCol="0" anchor="ctr"/>
+          <a:lstStyle/>
+          <a:p>
+            <a:pPr indent="0" marL="0">
+              <a:buNone/>
+            </a:pPr>
+            <a:r>
+              <a:rPr lang="en-US" sz="1600" b="1" dirty="0">
+                <a:solidFill>
+                  <a:srgbClr val="E8006A"/>
+                </a:solidFill>
+                <a:latin typeface="Barlow Condensed" pitchFamily="34" charset="0"/>
+                <a:ea typeface="Barlow Condensed" pitchFamily="34" charset="-122"/>
+                <a:cs typeface="Barlow Condensed" pitchFamily="34" charset="-120"/>
+              </a:rPr>
+              <a:t>01</a:t>
+            </a:r>
+            <a:endParaRPr lang="en-US" sz="1600" dirty="0"/>
+          </a:p>
+        </p:txBody>
+      </p:sp>
+      <p:sp>
+        <p:nvSpPr>
+          <p:cNvPr id="16" name="Text 14"/>
+          <p:cNvSpPr/>
+          <p:nvPr/>
+        </p:nvSpPr>
+        <p:spPr>
+          <a:xfrm>
+            <a:off x="1115568" y="3456432"/>
+            <a:ext cx="2468880" cy="365760"/>
+          </a:xfrm>
+          <a:prstGeom prst="rect">
+            <a:avLst/>
+          </a:prstGeom>
+          <a:noFill/>
+          <a:ln/>
+        </p:spPr>
+        <p:txBody>
+          <a:bodyPr wrap="square" rtlCol="0" anchor="ctr"/>
+          <a:lstStyle/>
+          <a:p>
+            <a:pPr indent="0" marL="0">
+              <a:buNone/>
+            </a:pPr>
+            <a:r>
+              <a:rPr lang="en-US" sz="2700" b="1" dirty="0">
                 <a:solidFill>
                   <a:srgbClr val="0F0F0F"/>
+                </a:solidFill>
+                <a:latin typeface="Barlow Condensed" pitchFamily="34" charset="0"/>
+                <a:ea typeface="Barlow Condensed" pitchFamily="34" charset="-122"/>
+                <a:cs typeface="Barlow Condensed" pitchFamily="34" charset="-120"/>
+              </a:rPr>
+              <a:t>START</a:t>
+            </a:r>
+            <a:endParaRPr lang="en-US" sz="2700" dirty="0"/>
+          </a:p>
+        </p:txBody>
+      </p:sp>
+      <p:sp>
+        <p:nvSpPr>
+          <p:cNvPr id="17" name="Text 15"/>
+          <p:cNvSpPr/>
+          <p:nvPr/>
+        </p:nvSpPr>
+        <p:spPr>
+          <a:xfrm>
+            <a:off x="1115568" y="3931920"/>
+            <a:ext cx="2926080" cy="1234440"/>
+          </a:xfrm>
+          <a:prstGeom prst="rect">
+            <a:avLst/>
+          </a:prstGeom>
+          <a:noFill/>
+          <a:ln/>
+        </p:spPr>
+        <p:txBody>
+          <a:bodyPr wrap="square" rtlCol="0" anchor="t"/>
+          <a:lstStyle/>
+          <a:p>
+            <a:pPr indent="0" marL="0">
+              <a:buNone/>
+            </a:pPr>
+            <a:r>
+              <a:rPr lang="en-US" sz="1500" dirty="0">
+                <a:solidFill>
+                  <a:srgbClr val="6B6B6B"/>
                 </a:solidFill>
                 <a:latin typeface="Barlow" pitchFamily="34" charset="0"/>
                 <a:ea typeface="Barlow" pitchFamily="34" charset="-122"/>
                 <a:cs typeface="Barlow" pitchFamily="34" charset="-120"/>
               </a:rPr>
-              <a:t>Replace with a strong insight, user quote, or key lesson from the project.</a:t>
+              <a:t>Problem framing and success criteria</a:t>
+            </a:r>
+            <a:endParaRPr lang="en-US" sz="1500" dirty="0"/>
+          </a:p>
+        </p:txBody>
+      </p:sp>
+      <p:sp>
+        <p:nvSpPr>
+          <p:cNvPr id="18" name="Shape 16"/>
+          <p:cNvSpPr/>
+          <p:nvPr/>
+        </p:nvSpPr>
+        <p:spPr>
+          <a:xfrm>
+            <a:off x="4407408" y="2971800"/>
+            <a:ext cx="3383280" cy="2697480"/>
+          </a:xfrm>
+          <a:prstGeom prst="roundRect">
+            <a:avLst>
+              <a:gd name="adj" fmla="val 2712"/>
+            </a:avLst>
+          </a:prstGeom>
+          <a:solidFill>
+            <a:srgbClr val="FFFAF4"/>
+          </a:solidFill>
+          <a:ln w="12700">
+            <a:solidFill>
+              <a:srgbClr val="D8C5AE"/>
+            </a:solidFill>
+            <a:prstDash val="solid"/>
+          </a:ln>
+        </p:spPr>
+      </p:sp>
+      <p:sp>
+        <p:nvSpPr>
+          <p:cNvPr id="19" name="Text 17"/>
+          <p:cNvSpPr/>
+          <p:nvPr/>
+        </p:nvSpPr>
+        <p:spPr>
+          <a:xfrm>
+            <a:off x="4654296" y="3154680"/>
+            <a:ext cx="548640" cy="237744"/>
+          </a:xfrm>
+          <a:prstGeom prst="rect">
+            <a:avLst/>
+          </a:prstGeom>
+          <a:noFill/>
+          <a:ln/>
+        </p:spPr>
+        <p:txBody>
+          <a:bodyPr wrap="square" rtlCol="0" anchor="ctr"/>
+          <a:lstStyle/>
+          <a:p>
+            <a:pPr indent="0" marL="0">
+              <a:buNone/>
+            </a:pPr>
+            <a:r>
+              <a:rPr lang="en-US" sz="1600" b="1" dirty="0">
+                <a:solidFill>
+                  <a:srgbClr val="2A7D5B"/>
+                </a:solidFill>
+                <a:latin typeface="Barlow Condensed" pitchFamily="34" charset="0"/>
+                <a:ea typeface="Barlow Condensed" pitchFamily="34" charset="-122"/>
+                <a:cs typeface="Barlow Condensed" pitchFamily="34" charset="-120"/>
+              </a:rPr>
+              <a:t>02</a:t>
+            </a:r>
+            <a:endParaRPr lang="en-US" sz="1600" dirty="0"/>
+          </a:p>
+        </p:txBody>
+      </p:sp>
+      <p:sp>
+        <p:nvSpPr>
+          <p:cNvPr id="20" name="Text 18"/>
+          <p:cNvSpPr/>
+          <p:nvPr/>
+        </p:nvSpPr>
+        <p:spPr>
+          <a:xfrm>
+            <a:off x="4654296" y="3456432"/>
+            <a:ext cx="2468880" cy="365760"/>
+          </a:xfrm>
+          <a:prstGeom prst="rect">
+            <a:avLst/>
+          </a:prstGeom>
+          <a:noFill/>
+          <a:ln/>
+        </p:spPr>
+        <p:txBody>
+          <a:bodyPr wrap="square" rtlCol="0" anchor="ctr"/>
+          <a:lstStyle/>
+          <a:p>
+            <a:pPr indent="0" marL="0">
+              <a:buNone/>
+            </a:pPr>
+            <a:r>
+              <a:rPr lang="en-US" sz="2700" b="1" dirty="0">
+                <a:solidFill>
+                  <a:srgbClr val="0F0F0F"/>
+                </a:solidFill>
+                <a:latin typeface="Barlow Condensed" pitchFamily="34" charset="0"/>
+                <a:ea typeface="Barlow Condensed" pitchFamily="34" charset="-122"/>
+                <a:cs typeface="Barlow Condensed" pitchFamily="34" charset="-120"/>
+              </a:rPr>
+              <a:t>BUILD</a:t>
             </a:r>
             <a:endParaRPr lang="en-US" sz="2700" dirty="0"/>
           </a:p>
@@ -3317,30 +4478,30 @@
       </p:sp>
       <p:sp>
         <p:nvSpPr>
-          <p:cNvPr id="15" name="Text 13"/>
-          <p:cNvSpPr/>
-          <p:nvPr/>
-        </p:nvSpPr>
-        <p:spPr>
-          <a:xfrm>
-            <a:off x="2194560" y="4681728"/>
-            <a:ext cx="8138160" cy="274320"/>
-          </a:xfrm>
-          <a:prstGeom prst="rect">
-            <a:avLst/>
-          </a:prstGeom>
-          <a:noFill/>
-          <a:ln/>
-        </p:spPr>
-        <p:txBody>
-          <a:bodyPr wrap="square" rtlCol="0" anchor="ctr"/>
-          <a:lstStyle/>
-          <a:p>
-            <a:pPr algn="ctr" indent="0" marL="0">
-              <a:buNone/>
-            </a:pPr>
-            <a:r>
-              <a:rPr lang="en-US" sz="1400" dirty="0">
+          <p:cNvPr id="21" name="Text 19"/>
+          <p:cNvSpPr/>
+          <p:nvPr/>
+        </p:nvSpPr>
+        <p:spPr>
+          <a:xfrm>
+            <a:off x="4654296" y="3931920"/>
+            <a:ext cx="2926080" cy="1234440"/>
+          </a:xfrm>
+          <a:prstGeom prst="rect">
+            <a:avLst/>
+          </a:prstGeom>
+          <a:noFill/>
+          <a:ln/>
+        </p:spPr>
+        <p:txBody>
+          <a:bodyPr wrap="square" rtlCol="0" anchor="t"/>
+          <a:lstStyle/>
+          <a:p>
+            <a:pPr indent="0" marL="0">
+              <a:buNone/>
+            </a:pPr>
+            <a:r>
+              <a:rPr lang="en-US" sz="1500" dirty="0">
                 <a:solidFill>
                   <a:srgbClr val="6B6B6B"/>
                 </a:solidFill>
@@ -3348,45 +4509,49 @@
                 <a:ea typeface="Barlow" pitchFamily="34" charset="-122"/>
                 <a:cs typeface="Barlow" pitchFamily="34" charset="-120"/>
               </a:rPr>
-              <a:t>Attribution / Source</a:t>
-            </a:r>
-            <a:endParaRPr lang="en-US" sz="1400" dirty="0"/>
-          </a:p>
-        </p:txBody>
-      </p:sp>
-      <p:sp>
-        <p:nvSpPr>
-          <p:cNvPr id="16" name="Shape 14"/>
-          <p:cNvSpPr/>
-          <p:nvPr/>
-        </p:nvSpPr>
-        <p:spPr>
-          <a:xfrm>
-            <a:off x="457200" y="6446520"/>
-            <a:ext cx="11277295" cy="0"/>
-          </a:xfrm>
-          <a:prstGeom prst="line">
-            <a:avLst/>
-          </a:prstGeom>
-          <a:noFill/>
-          <a:ln w="12700">
-            <a:solidFill>
-              <a:srgbClr val="D7D7D7"/>
-            </a:solidFill>
-            <a:prstDash val="solid"/>
-          </a:ln>
-        </p:spPr>
-      </p:sp>
-      <p:sp>
-        <p:nvSpPr>
-          <p:cNvPr id="17" name="Text 15"/>
-          <p:cNvSpPr/>
-          <p:nvPr/>
-        </p:nvSpPr>
-        <p:spPr>
-          <a:xfrm>
-            <a:off x="457200" y="6473952"/>
-            <a:ext cx="3657600" cy="182880"/>
+              <a:t>Approach, trade-offs, and technical decisions</a:t>
+            </a:r>
+            <a:endParaRPr lang="en-US" sz="1500" dirty="0"/>
+          </a:p>
+        </p:txBody>
+      </p:sp>
+      <p:sp>
+        <p:nvSpPr>
+          <p:cNvPr id="22" name="Shape 20"/>
+          <p:cNvSpPr/>
+          <p:nvPr/>
+        </p:nvSpPr>
+        <p:spPr>
+          <a:xfrm>
+            <a:off x="7946136" y="2971800"/>
+            <a:ext cx="3383280" cy="2697480"/>
+          </a:xfrm>
+          <a:prstGeom prst="roundRect">
+            <a:avLst>
+              <a:gd name="adj" fmla="val 2712"/>
+            </a:avLst>
+          </a:prstGeom>
+          <a:solidFill>
+            <a:srgbClr val="E5D8C9"/>
+          </a:solidFill>
+          <a:ln w="12700">
+            <a:solidFill>
+              <a:srgbClr val="D8C5AE"/>
+            </a:solidFill>
+            <a:prstDash val="solid"/>
+          </a:ln>
+        </p:spPr>
+      </p:sp>
+      <p:sp>
+        <p:nvSpPr>
+          <p:cNvPr id="23" name="Text 21"/>
+          <p:cNvSpPr/>
+          <p:nvPr/>
+        </p:nvSpPr>
+        <p:spPr>
+          <a:xfrm>
+            <a:off x="8193024" y="3154680"/>
+            <a:ext cx="548640" cy="237744"/>
           </a:xfrm>
           <a:prstGeom prst="rect">
             <a:avLst/>
@@ -3402,7 +4567,85 @@
               <a:buNone/>
             </a:pPr>
             <a:r>
-              <a:rPr lang="en-US" sz="1000" dirty="0">
+              <a:rPr lang="en-US" sz="1600" b="1" dirty="0">
+                <a:solidFill>
+                  <a:srgbClr val="1B5A40"/>
+                </a:solidFill>
+                <a:latin typeface="Barlow Condensed" pitchFamily="34" charset="0"/>
+                <a:ea typeface="Barlow Condensed" pitchFamily="34" charset="-122"/>
+                <a:cs typeface="Barlow Condensed" pitchFamily="34" charset="-120"/>
+              </a:rPr>
+              <a:t>03</a:t>
+            </a:r>
+            <a:endParaRPr lang="en-US" sz="1600" dirty="0"/>
+          </a:p>
+        </p:txBody>
+      </p:sp>
+      <p:sp>
+        <p:nvSpPr>
+          <p:cNvPr id="24" name="Text 22"/>
+          <p:cNvSpPr/>
+          <p:nvPr/>
+        </p:nvSpPr>
+        <p:spPr>
+          <a:xfrm>
+            <a:off x="8193024" y="3456432"/>
+            <a:ext cx="2468880" cy="365760"/>
+          </a:xfrm>
+          <a:prstGeom prst="rect">
+            <a:avLst/>
+          </a:prstGeom>
+          <a:noFill/>
+          <a:ln/>
+        </p:spPr>
+        <p:txBody>
+          <a:bodyPr wrap="square" rtlCol="0" anchor="ctr"/>
+          <a:lstStyle/>
+          <a:p>
+            <a:pPr indent="0" marL="0">
+              <a:buNone/>
+            </a:pPr>
+            <a:r>
+              <a:rPr lang="en-US" sz="2700" b="1" dirty="0">
+                <a:solidFill>
+                  <a:srgbClr val="0F0F0F"/>
+                </a:solidFill>
+                <a:latin typeface="Barlow Condensed" pitchFamily="34" charset="0"/>
+                <a:ea typeface="Barlow Condensed" pitchFamily="34" charset="-122"/>
+                <a:cs typeface="Barlow Condensed" pitchFamily="34" charset="-120"/>
+              </a:rPr>
+              <a:t>SHIP</a:t>
+            </a:r>
+            <a:endParaRPr lang="en-US" sz="2700" dirty="0"/>
+          </a:p>
+        </p:txBody>
+      </p:sp>
+      <p:sp>
+        <p:nvSpPr>
+          <p:cNvPr id="25" name="Text 23"/>
+          <p:cNvSpPr/>
+          <p:nvPr/>
+        </p:nvSpPr>
+        <p:spPr>
+          <a:xfrm>
+            <a:off x="8193024" y="3931920"/>
+            <a:ext cx="2926080" cy="1234440"/>
+          </a:xfrm>
+          <a:prstGeom prst="rect">
+            <a:avLst/>
+          </a:prstGeom>
+          <a:noFill/>
+          <a:ln/>
+        </p:spPr>
+        <p:txBody>
+          <a:bodyPr wrap="square" rtlCol="0" anchor="t"/>
+          <a:lstStyle/>
+          <a:p>
+            <a:pPr indent="0" marL="0">
+              <a:buNone/>
+            </a:pPr>
+            <a:r>
+              <a:rPr lang="en-US" sz="1500" dirty="0">
                 <a:solidFill>
                   <a:srgbClr val="6B6B6B"/>
                 </a:solidFill>
@@ -3410,6 +4653,68 @@
                 <a:ea typeface="Barlow" pitchFamily="34" charset="-122"/>
                 <a:cs typeface="Barlow" pitchFamily="34" charset="-120"/>
               </a:rPr>
+              <a:t>Outcomes, metrics, and next guide steps</a:t>
+            </a:r>
+            <a:endParaRPr lang="en-US" sz="1500" dirty="0"/>
+          </a:p>
+        </p:txBody>
+      </p:sp>
+      <p:sp>
+        <p:nvSpPr>
+          <p:cNvPr id="26" name="Shape 24"/>
+          <p:cNvSpPr/>
+          <p:nvPr/>
+        </p:nvSpPr>
+        <p:spPr>
+          <a:xfrm>
+            <a:off x="457200" y="6446520"/>
+            <a:ext cx="11277295" cy="0"/>
+          </a:xfrm>
+          <a:prstGeom prst="line">
+            <a:avLst/>
+          </a:prstGeom>
+          <a:noFill/>
+          <a:ln w="12700">
+            <a:solidFill>
+              <a:srgbClr val="D7D7D7"/>
+            </a:solidFill>
+            <a:prstDash val="solid"/>
+          </a:ln>
+        </p:spPr>
+      </p:sp>
+      <p:sp>
+        <p:nvSpPr>
+          <p:cNvPr id="27" name="Text 25"/>
+          <p:cNvSpPr/>
+          <p:nvPr/>
+        </p:nvSpPr>
+        <p:spPr>
+          <a:xfrm>
+            <a:off x="457200" y="6473952"/>
+            <a:ext cx="3657600" cy="182880"/>
+          </a:xfrm>
+          <a:prstGeom prst="rect">
+            <a:avLst/>
+          </a:prstGeom>
+          <a:noFill/>
+          <a:ln/>
+        </p:spPr>
+        <p:txBody>
+          <a:bodyPr wrap="square" rtlCol="0" anchor="ctr"/>
+          <a:lstStyle/>
+          <a:p>
+            <a:pPr indent="0" marL="0">
+              <a:buNone/>
+            </a:pPr>
+            <a:r>
+              <a:rPr lang="en-US" sz="1000" dirty="0">
+                <a:solidFill>
+                  <a:srgbClr val="6B6B6B"/>
+                </a:solidFill>
+                <a:latin typeface="Barlow" pitchFamily="34" charset="0"/>
+                <a:ea typeface="Barlow" pitchFamily="34" charset="-122"/>
+                <a:cs typeface="Barlow" pitchFamily="34" charset="-120"/>
+              </a:rPr>
               <a:t>sourcier.uk</a:t>
             </a:r>
             <a:endParaRPr lang="en-US" sz="1000" dirty="0"/>
@@ -3418,7 +4723,7 @@
       </p:sp>
       <p:sp>
         <p:nvSpPr>
-          <p:cNvPr id="18" name="Text 16"/>
+          <p:cNvPr id="28" name="Text 26"/>
           <p:cNvSpPr/>
           <p:nvPr/>
         </p:nvSpPr>
@@ -3727,7 +5032,7 @@
                 <a:ea typeface="Barlow Condensed" pitchFamily="34" charset="-122"/>
                 <a:cs typeface="Barlow Condensed" pitchFamily="34" charset="-120"/>
               </a:rPr>
-              <a:t>IMAGE + CAPTION</a:t>
+              <a:t>WORKING SLIDE</a:t>
             </a:r>
             <a:endParaRPr lang="en-US" sz="3400" dirty="0"/>
           </a:p>
@@ -3766,7 +5071,7 @@
                 <a:ea typeface="Barlow" pitchFamily="34" charset="-122"/>
                 <a:cs typeface="Barlow" pitchFamily="34" charset="-120"/>
               </a:rPr>
-              <a:t>Use for screenshots, architecture diagrams, or mockups.</a:t>
+              <a:t>Two-column layout for argument + evidence.</a:t>
             </a:r>
             <a:endParaRPr lang="en-US" sz="1800" dirty="0"/>
           </a:p>
@@ -3780,8 +5085,8 @@
         </p:nvSpPr>
         <p:spPr>
           <a:xfrm>
-            <a:off x="731520" y="2011680"/>
-            <a:ext cx="10744200" cy="3931920"/>
+            <a:off x="457200" y="2148840"/>
+            <a:ext cx="5440680" cy="3977640"/>
           </a:xfrm>
           <a:prstGeom prst="rect">
             <a:avLst/>
@@ -3805,43 +5110,61 @@
         </p:nvSpPr>
         <p:spPr>
           <a:xfrm>
-            <a:off x="731520" y="2011680"/>
-            <a:ext cx="10744200" cy="3931920"/>
-          </a:xfrm>
-          <a:prstGeom prst="line">
-            <a:avLst/>
-          </a:prstGeom>
-          <a:noFill/>
-          <a:ln w="12700">
-            <a:solidFill>
-              <a:srgbClr val="D7D7D7"/>
-            </a:solidFill>
-            <a:prstDash val="solid"/>
-          </a:ln>
-        </p:spPr>
-      </p:sp>
-      <p:sp>
-        <p:nvSpPr>
-          <p:cNvPr id="13" name="Shape 11"/>
-          <p:cNvSpPr/>
-          <p:nvPr/>
-        </p:nvSpPr>
-        <p:spPr>
-          <a:xfrm>
-            <a:off x="11475720" y="2011680"/>
-            <a:ext cx="-10744200" cy="3931920"/>
-          </a:xfrm>
-          <a:prstGeom prst="line">
-            <a:avLst/>
-          </a:prstGeom>
-          <a:noFill/>
-          <a:ln w="12700">
-            <a:solidFill>
-              <a:srgbClr val="D7D7D7"/>
-            </a:solidFill>
-            <a:prstDash val="solid"/>
-          </a:ln>
-        </p:spPr>
+            <a:off x="6291072" y="2148840"/>
+            <a:ext cx="5440680" cy="3977640"/>
+          </a:xfrm>
+          <a:prstGeom prst="rect">
+            <a:avLst/>
+          </a:prstGeom>
+          <a:solidFill>
+            <a:srgbClr val="FFFAF4"/>
+          </a:solidFill>
+          <a:ln w="12700">
+            <a:solidFill>
+              <a:srgbClr val="D8C5AE"/>
+            </a:solidFill>
+            <a:prstDash val="solid"/>
+          </a:ln>
+        </p:spPr>
+      </p:sp>
+      <p:sp>
+        <p:nvSpPr>
+          <p:cNvPr id="13" name="Text 11"/>
+          <p:cNvSpPr/>
+          <p:nvPr/>
+        </p:nvSpPr>
+        <p:spPr>
+          <a:xfrm>
+            <a:off x="786384" y="2487168"/>
+            <a:ext cx="4754880" cy="347472"/>
+          </a:xfrm>
+          <a:prstGeom prst="rect">
+            <a:avLst/>
+          </a:prstGeom>
+          <a:noFill/>
+          <a:ln/>
+        </p:spPr>
+        <p:txBody>
+          <a:bodyPr wrap="square" rtlCol="0" anchor="ctr"/>
+          <a:lstStyle/>
+          <a:p>
+            <a:pPr indent="0" marL="0">
+              <a:buNone/>
+            </a:pPr>
+            <a:r>
+              <a:rPr lang="en-US" sz="2400" b="1" dirty="0">
+                <a:solidFill>
+                  <a:srgbClr val="0F0F0F"/>
+                </a:solidFill>
+                <a:latin typeface="Barlow Condensed" pitchFamily="34" charset="0"/>
+                <a:ea typeface="Barlow Condensed" pitchFamily="34" charset="-122"/>
+                <a:cs typeface="Barlow Condensed" pitchFamily="34" charset="-120"/>
+              </a:rPr>
+              <a:t>Argument</a:t>
+            </a:r>
+            <a:endParaRPr lang="en-US" sz="2400" dirty="0"/>
+          </a:p>
+        </p:txBody>
       </p:sp>
       <p:sp>
         <p:nvSpPr>
@@ -3851,132 +5174,232 @@
         </p:nvSpPr>
         <p:spPr>
           <a:xfrm>
-            <a:off x="4892040" y="3867912"/>
-            <a:ext cx="2423160" cy="274320"/>
-          </a:xfrm>
-          <a:prstGeom prst="rect">
-            <a:avLst/>
-          </a:prstGeom>
-          <a:noFill/>
-          <a:ln/>
-        </p:spPr>
-        <p:txBody>
-          <a:bodyPr wrap="square" rtlCol="0" anchor="ctr"/>
-          <a:lstStyle/>
-          <a:p>
-            <a:pPr algn="ctr" indent="0" marL="0">
-              <a:buNone/>
-            </a:pPr>
-            <a:r>
-              <a:rPr lang="en-US" sz="1400" dirty="0">
-                <a:solidFill>
-                  <a:srgbClr val="6B6B6B"/>
+            <a:off x="786384" y="2971800"/>
+            <a:ext cx="4754880" cy="2834640"/>
+          </a:xfrm>
+          <a:prstGeom prst="rect">
+            <a:avLst/>
+          </a:prstGeom>
+          <a:noFill/>
+          <a:ln/>
+        </p:spPr>
+        <p:txBody>
+          <a:bodyPr wrap="square" rtlCol="0" anchor="t"/>
+          <a:lstStyle/>
+          <a:p>
+            <a:pPr indent="0" marL="0">
+              <a:buNone/>
+            </a:pPr>
+            <a:r>
+              <a:rPr lang="en-US" sz="1700" dirty="0">
+                <a:solidFill>
+                  <a:srgbClr val="0F0F0F"/>
                 </a:solidFill>
                 <a:latin typeface="Barlow" pitchFamily="34" charset="0"/>
                 <a:ea typeface="Barlow" pitchFamily="34" charset="-122"/>
                 <a:cs typeface="Barlow" pitchFamily="34" charset="-120"/>
               </a:rPr>
-              <a:t>Replace with image</a:t>
-            </a:r>
-            <a:endParaRPr lang="en-US" sz="1400" dirty="0"/>
-          </a:p>
-        </p:txBody>
-      </p:sp>
-      <p:sp>
-        <p:nvSpPr>
-          <p:cNvPr id="15" name="Text 13"/>
-          <p:cNvSpPr/>
-          <p:nvPr/>
-        </p:nvSpPr>
-        <p:spPr>
-          <a:xfrm>
-            <a:off x="731520" y="6080760"/>
-            <a:ext cx="10744200" cy="320040"/>
-          </a:xfrm>
-          <a:prstGeom prst="rect">
-            <a:avLst/>
-          </a:prstGeom>
-          <a:noFill/>
-          <a:ln/>
-        </p:spPr>
-        <p:txBody>
-          <a:bodyPr wrap="square" rtlCol="0" anchor="ctr"/>
-          <a:lstStyle/>
+              <a:t>- Context and constraint</a:t>
+            </a:r>
+            <a:endParaRPr lang="en-US" sz="1700" dirty="0"/>
+          </a:p>
           <a:p>
             <a:pPr indent="0" marL="0">
               <a:buNone/>
             </a:pPr>
             <a:r>
-              <a:rPr lang="en-US" sz="1500" dirty="0">
-                <a:solidFill>
-                  <a:srgbClr val="6B6B6B"/>
+              <a:rPr lang="en-US" sz="1700" dirty="0">
+                <a:solidFill>
+                  <a:srgbClr val="0F0F0F"/>
                 </a:solidFill>
                 <a:latin typeface="Barlow" pitchFamily="34" charset="0"/>
                 <a:ea typeface="Barlow" pitchFamily="34" charset="-122"/>
                 <a:cs typeface="Barlow" pitchFamily="34" charset="-120"/>
               </a:rPr>
-              <a:t>Caption or callout text can go here.</a:t>
-            </a:r>
-            <a:endParaRPr lang="en-US" sz="1500" dirty="0"/>
-          </a:p>
-        </p:txBody>
-      </p:sp>
-      <p:sp>
-        <p:nvSpPr>
-          <p:cNvPr id="16" name="Shape 14"/>
-          <p:cNvSpPr/>
-          <p:nvPr/>
-        </p:nvSpPr>
-        <p:spPr>
-          <a:xfrm>
-            <a:off x="457200" y="6446520"/>
-            <a:ext cx="11277295" cy="0"/>
-          </a:xfrm>
-          <a:prstGeom prst="line">
-            <a:avLst/>
-          </a:prstGeom>
-          <a:noFill/>
-          <a:ln w="12700">
-            <a:solidFill>
-              <a:srgbClr val="D7D7D7"/>
-            </a:solidFill>
-            <a:prstDash val="solid"/>
-          </a:ln>
-        </p:spPr>
-      </p:sp>
-      <p:sp>
-        <p:nvSpPr>
-          <p:cNvPr id="17" name="Text 15"/>
-          <p:cNvSpPr/>
-          <p:nvPr/>
-        </p:nvSpPr>
-        <p:spPr>
-          <a:xfrm>
-            <a:off x="457200" y="6473952"/>
-            <a:ext cx="3657600" cy="182880"/>
-          </a:xfrm>
-          <a:prstGeom prst="rect">
-            <a:avLst/>
-          </a:prstGeom>
-          <a:noFill/>
-          <a:ln/>
-        </p:spPr>
-        <p:txBody>
-          <a:bodyPr wrap="square" rtlCol="0" anchor="ctr"/>
-          <a:lstStyle/>
+              <a:t>- Key decision</a:t>
+            </a:r>
+            <a:endParaRPr lang="en-US" sz="1700" dirty="0"/>
+          </a:p>
           <a:p>
             <a:pPr indent="0" marL="0">
               <a:buNone/>
             </a:pPr>
             <a:r>
-              <a:rPr lang="en-US" sz="1000" dirty="0">
-                <a:solidFill>
-                  <a:srgbClr val="6B6B6B"/>
+              <a:rPr lang="en-US" sz="1700" dirty="0">
+                <a:solidFill>
+                  <a:srgbClr val="0F0F0F"/>
                 </a:solidFill>
                 <a:latin typeface="Barlow" pitchFamily="34" charset="0"/>
                 <a:ea typeface="Barlow" pitchFamily="34" charset="-122"/>
                 <a:cs typeface="Barlow" pitchFamily="34" charset="-120"/>
               </a:rPr>
+              <a:t>- Why this approach won</a:t>
+            </a:r>
+            <a:endParaRPr lang="en-US" sz="1700" dirty="0"/>
+          </a:p>
+        </p:txBody>
+      </p:sp>
+      <p:sp>
+        <p:nvSpPr>
+          <p:cNvPr id="15" name="Text 13"/>
+          <p:cNvSpPr/>
+          <p:nvPr/>
+        </p:nvSpPr>
+        <p:spPr>
+          <a:xfrm>
+            <a:off x="6620256" y="2487168"/>
+            <a:ext cx="4754880" cy="347472"/>
+          </a:xfrm>
+          <a:prstGeom prst="rect">
+            <a:avLst/>
+          </a:prstGeom>
+          <a:noFill/>
+          <a:ln/>
+        </p:spPr>
+        <p:txBody>
+          <a:bodyPr wrap="square" rtlCol="0" anchor="ctr"/>
+          <a:lstStyle/>
+          <a:p>
+            <a:pPr indent="0" marL="0">
+              <a:buNone/>
+            </a:pPr>
+            <a:r>
+              <a:rPr lang="en-US" sz="2400" b="1" dirty="0">
+                <a:solidFill>
+                  <a:srgbClr val="0F0F0F"/>
+                </a:solidFill>
+                <a:latin typeface="Barlow Condensed" pitchFamily="34" charset="0"/>
+                <a:ea typeface="Barlow Condensed" pitchFamily="34" charset="-122"/>
+                <a:cs typeface="Barlow Condensed" pitchFamily="34" charset="-120"/>
+              </a:rPr>
+              <a:t>Evidence</a:t>
+            </a:r>
+            <a:endParaRPr lang="en-US" sz="2400" dirty="0"/>
+          </a:p>
+        </p:txBody>
+      </p:sp>
+      <p:sp>
+        <p:nvSpPr>
+          <p:cNvPr id="16" name="Shape 14"/>
+          <p:cNvSpPr/>
+          <p:nvPr/>
+        </p:nvSpPr>
+        <p:spPr>
+          <a:xfrm>
+            <a:off x="6620256" y="2971800"/>
+            <a:ext cx="4754880" cy="2834640"/>
+          </a:xfrm>
+          <a:prstGeom prst="roundRect">
+            <a:avLst>
+              <a:gd name="adj" fmla="val 2581"/>
+            </a:avLst>
+          </a:prstGeom>
+          <a:solidFill>
+            <a:srgbClr val="F6ECE1"/>
+          </a:solidFill>
+          <a:ln w="12700">
+            <a:solidFill>
+              <a:srgbClr val="D8C5AE"/>
+            </a:solidFill>
+            <a:prstDash val="solid"/>
+          </a:ln>
+        </p:spPr>
+      </p:sp>
+      <p:sp>
+        <p:nvSpPr>
+          <p:cNvPr id="17" name="Text 15"/>
+          <p:cNvSpPr/>
+          <p:nvPr/>
+        </p:nvSpPr>
+        <p:spPr>
+          <a:xfrm>
+            <a:off x="6858000" y="4160520"/>
+            <a:ext cx="4297680" cy="320040"/>
+          </a:xfrm>
+          <a:prstGeom prst="rect">
+            <a:avLst/>
+          </a:prstGeom>
+          <a:noFill/>
+          <a:ln/>
+        </p:spPr>
+        <p:txBody>
+          <a:bodyPr wrap="square" rtlCol="0" anchor="ctr"/>
+          <a:lstStyle/>
+          <a:p>
+            <a:pPr algn="ctr" indent="0" marL="0">
+              <a:buNone/>
+            </a:pPr>
+            <a:r>
+              <a:rPr lang="en-US" sz="1400" dirty="0">
+                <a:solidFill>
+                  <a:srgbClr val="6B6B6B"/>
+                </a:solidFill>
+                <a:latin typeface="Barlow" pitchFamily="34" charset="0"/>
+                <a:ea typeface="Barlow" pitchFamily="34" charset="-122"/>
+                <a:cs typeface="Barlow" pitchFamily="34" charset="-120"/>
+              </a:rPr>
+              <a:t>Drop chart, screenshot, or code snippet</a:t>
+            </a:r>
+            <a:endParaRPr lang="en-US" sz="1400" dirty="0"/>
+          </a:p>
+        </p:txBody>
+      </p:sp>
+      <p:sp>
+        <p:nvSpPr>
+          <p:cNvPr id="18" name="Shape 16"/>
+          <p:cNvSpPr/>
+          <p:nvPr/>
+        </p:nvSpPr>
+        <p:spPr>
+          <a:xfrm>
+            <a:off x="457200" y="6446520"/>
+            <a:ext cx="11277295" cy="0"/>
+          </a:xfrm>
+          <a:prstGeom prst="line">
+            <a:avLst/>
+          </a:prstGeom>
+          <a:noFill/>
+          <a:ln w="12700">
+            <a:solidFill>
+              <a:srgbClr val="D7D7D7"/>
+            </a:solidFill>
+            <a:prstDash val="solid"/>
+          </a:ln>
+        </p:spPr>
+      </p:sp>
+      <p:sp>
+        <p:nvSpPr>
+          <p:cNvPr id="19" name="Text 17"/>
+          <p:cNvSpPr/>
+          <p:nvPr/>
+        </p:nvSpPr>
+        <p:spPr>
+          <a:xfrm>
+            <a:off x="457200" y="6473952"/>
+            <a:ext cx="3657600" cy="182880"/>
+          </a:xfrm>
+          <a:prstGeom prst="rect">
+            <a:avLst/>
+          </a:prstGeom>
+          <a:noFill/>
+          <a:ln/>
+        </p:spPr>
+        <p:txBody>
+          <a:bodyPr wrap="square" rtlCol="0" anchor="ctr"/>
+          <a:lstStyle/>
+          <a:p>
+            <a:pPr indent="0" marL="0">
+              <a:buNone/>
+            </a:pPr>
+            <a:r>
+              <a:rPr lang="en-US" sz="1000" dirty="0">
+                <a:solidFill>
+                  <a:srgbClr val="6B6B6B"/>
+                </a:solidFill>
+                <a:latin typeface="Barlow" pitchFamily="34" charset="0"/>
+                <a:ea typeface="Barlow" pitchFamily="34" charset="-122"/>
+                <a:cs typeface="Barlow" pitchFamily="34" charset="-120"/>
+              </a:rPr>
               <a:t>sourcier.uk</a:t>
             </a:r>
             <a:endParaRPr lang="en-US" sz="1000" dirty="0"/>
@@ -3985,7 +5408,7 @@
       </p:sp>
       <p:sp>
         <p:nvSpPr>
-          <p:cNvPr id="18" name="Text 16"/>
+          <p:cNvPr id="20" name="Text 18"/>
           <p:cNvSpPr/>
           <p:nvPr/>
         </p:nvSpPr>
@@ -4033,6 +5456,1990 @@
 <file path=ppt/slides/slide6.xml><?xml version="1.0" encoding="utf-8"?>
 <p:sld xmlns:a="http://schemas.openxmlformats.org/drawingml/2006/main" xmlns:r="http://schemas.openxmlformats.org/officeDocument/2006/relationships" xmlns:p="http://schemas.openxmlformats.org/presentationml/2006/main">
   <p:cSld name="Slide 6">
+    <p:bg>
+      <p:bgPr>
+        <a:solidFill>
+          <a:srgbClr val="F6ECE1"/>
+        </a:solidFill>
+      </p:bgPr>
+    </p:bg>
+    <p:spTree>
+      <p:nvGrpSpPr>
+        <p:cNvPr id="1" name=""/>
+        <p:cNvGrpSpPr/>
+        <p:nvPr/>
+      </p:nvGrpSpPr>
+      <p:grpSpPr>
+        <a:xfrm>
+          <a:off x="0" y="0"/>
+          <a:ext cx="0" cy="0"/>
+          <a:chOff x="0" y="0"/>
+          <a:chExt cx="0" cy="0"/>
+        </a:xfrm>
+      </p:grpSpPr>
+      <p:sp>
+        <p:nvSpPr>
+          <p:cNvPr id="2" name="Shape 0"/>
+          <p:cNvSpPr/>
+          <p:nvPr/>
+        </p:nvSpPr>
+        <p:spPr>
+          <a:xfrm>
+            <a:off x="-1920240" y="-1097280"/>
+            <a:ext cx="5394960" cy="4480560"/>
+          </a:xfrm>
+          <a:prstGeom prst="roundRect">
+            <a:avLst>
+              <a:gd name="adj" fmla="val 6122"/>
+            </a:avLst>
+          </a:prstGeom>
+          <a:solidFill>
+            <a:srgbClr val="E8006A">
+              <a:alpha val="8000"/>
+            </a:srgbClr>
+          </a:solidFill>
+          <a:ln w="12700">
+            <a:solidFill>
+              <a:srgbClr val="E8006A">
+                <a:alpha val="0"/>
+              </a:srgbClr>
+            </a:solidFill>
+            <a:prstDash val="solid"/>
+          </a:ln>
+        </p:spPr>
+      </p:sp>
+      <p:sp>
+        <p:nvSpPr>
+          <p:cNvPr id="3" name="Shape 1"/>
+          <p:cNvSpPr/>
+          <p:nvPr/>
+        </p:nvSpPr>
+        <p:spPr>
+          <a:xfrm>
+            <a:off x="8412480" y="-1371600"/>
+            <a:ext cx="5669280" cy="5120640"/>
+          </a:xfrm>
+          <a:prstGeom prst="roundRect">
+            <a:avLst>
+              <a:gd name="adj" fmla="val 5357"/>
+            </a:avLst>
+          </a:prstGeom>
+          <a:solidFill>
+            <a:srgbClr val="2A7D5B">
+              <a:alpha val="10000"/>
+            </a:srgbClr>
+          </a:solidFill>
+          <a:ln w="12700">
+            <a:solidFill>
+              <a:srgbClr val="2A7D5B">
+                <a:alpha val="0"/>
+              </a:srgbClr>
+            </a:solidFill>
+            <a:prstDash val="solid"/>
+          </a:ln>
+        </p:spPr>
+      </p:sp>
+      <p:sp>
+        <p:nvSpPr>
+          <p:cNvPr id="4" name="Shape 2"/>
+          <p:cNvSpPr/>
+          <p:nvPr/>
+        </p:nvSpPr>
+        <p:spPr>
+          <a:xfrm>
+            <a:off x="6492240" y="5029200"/>
+            <a:ext cx="7406640" cy="3108960"/>
+          </a:xfrm>
+          <a:prstGeom prst="roundRect">
+            <a:avLst>
+              <a:gd name="adj" fmla="val 8824"/>
+            </a:avLst>
+          </a:prstGeom>
+          <a:solidFill>
+            <a:srgbClr val="E5D8C9">
+              <a:alpha val="76000"/>
+            </a:srgbClr>
+          </a:solidFill>
+          <a:ln w="12700">
+            <a:solidFill>
+              <a:srgbClr val="E5D8C9">
+                <a:alpha val="0"/>
+              </a:srgbClr>
+            </a:solidFill>
+            <a:prstDash val="solid"/>
+          </a:ln>
+        </p:spPr>
+      </p:sp>
+      <p:sp>
+        <p:nvSpPr>
+          <p:cNvPr id="5" name="Shape 3"/>
+          <p:cNvSpPr/>
+          <p:nvPr/>
+        </p:nvSpPr>
+        <p:spPr>
+          <a:xfrm>
+            <a:off x="0" y="0"/>
+            <a:ext cx="12191695" cy="658368"/>
+          </a:xfrm>
+          <a:prstGeom prst="rect">
+            <a:avLst/>
+          </a:prstGeom>
+          <a:solidFill>
+            <a:srgbClr val="101410"/>
+          </a:solidFill>
+          <a:ln w="12700">
+            <a:solidFill>
+              <a:srgbClr val="101410"/>
+            </a:solidFill>
+            <a:prstDash val="solid"/>
+          </a:ln>
+        </p:spPr>
+      </p:sp>
+      <p:sp>
+        <p:nvSpPr>
+          <p:cNvPr id="6" name="Shape 4"/>
+          <p:cNvSpPr/>
+          <p:nvPr/>
+        </p:nvSpPr>
+        <p:spPr>
+          <a:xfrm>
+            <a:off x="0" y="658368"/>
+            <a:ext cx="12191695" cy="0"/>
+          </a:xfrm>
+          <a:prstGeom prst="line">
+            <a:avLst/>
+          </a:prstGeom>
+          <a:noFill/>
+          <a:ln w="12700">
+            <a:solidFill>
+              <a:srgbClr val="E8006A"/>
+            </a:solidFill>
+            <a:prstDash val="solid"/>
+          </a:ln>
+        </p:spPr>
+      </p:sp>
+      <p:sp>
+        <p:nvSpPr>
+          <p:cNvPr id="7" name="Shape 5"/>
+          <p:cNvSpPr/>
+          <p:nvPr/>
+        </p:nvSpPr>
+        <p:spPr>
+          <a:xfrm>
+            <a:off x="0" y="621792"/>
+            <a:ext cx="12191695" cy="0"/>
+          </a:xfrm>
+          <a:prstGeom prst="line">
+            <a:avLst/>
+          </a:prstGeom>
+          <a:noFill/>
+          <a:ln w="12700">
+            <a:solidFill>
+              <a:srgbClr val="2A7D5B">
+                <a:alpha val="76000"/>
+              </a:srgbClr>
+            </a:solidFill>
+            <a:prstDash val="solid"/>
+          </a:ln>
+        </p:spPr>
+      </p:sp>
+      <p:sp>
+        <p:nvSpPr>
+          <p:cNvPr id="8" name="Text 6"/>
+          <p:cNvSpPr/>
+          <p:nvPr/>
+        </p:nvSpPr>
+        <p:spPr>
+          <a:xfrm>
+            <a:off x="457200" y="155448"/>
+            <a:ext cx="2560320" cy="274320"/>
+          </a:xfrm>
+          <a:prstGeom prst="rect">
+            <a:avLst/>
+          </a:prstGeom>
+          <a:noFill/>
+          <a:ln/>
+        </p:spPr>
+        <p:txBody>
+          <a:bodyPr wrap="square" rtlCol="0" anchor="ctr"/>
+          <a:lstStyle/>
+          <a:p>
+            <a:pPr indent="0" marL="0">
+              <a:buNone/>
+            </a:pPr>
+            <a:r>
+              <a:rPr lang="en-US" sz="1800" b="1" dirty="0">
+                <a:solidFill>
+                  <a:srgbClr val="FFFFFF"/>
+                </a:solidFill>
+                <a:latin typeface="Barlow Condensed" pitchFamily="34" charset="0"/>
+                <a:ea typeface="Barlow Condensed" pitchFamily="34" charset="-122"/>
+                <a:cs typeface="Barlow Condensed" pitchFamily="34" charset="-120"/>
+              </a:rPr>
+              <a:t>SOURCIER</a:t>
+            </a:r>
+            <a:endParaRPr lang="en-US" sz="1800" dirty="0"/>
+          </a:p>
+        </p:txBody>
+      </p:sp>
+      <p:sp>
+        <p:nvSpPr>
+          <p:cNvPr id="9" name="Text 7"/>
+          <p:cNvSpPr/>
+          <p:nvPr/>
+        </p:nvSpPr>
+        <p:spPr>
+          <a:xfrm>
+            <a:off x="457200" y="914400"/>
+            <a:ext cx="7863840" cy="685800"/>
+          </a:xfrm>
+          <a:prstGeom prst="rect">
+            <a:avLst/>
+          </a:prstGeom>
+          <a:noFill/>
+          <a:ln/>
+        </p:spPr>
+        <p:txBody>
+          <a:bodyPr wrap="square" rtlCol="0" anchor="ctr">
+            <a:normAutofit/>
+          </a:bodyPr>
+          <a:lstStyle/>
+          <a:p>
+            <a:pPr indent="0" marL="0">
+              <a:buNone/>
+            </a:pPr>
+            <a:r>
+              <a:rPr lang="en-US" sz="3400" b="1" dirty="0">
+                <a:solidFill>
+                  <a:srgbClr val="0F0F0F"/>
+                </a:solidFill>
+                <a:latin typeface="Barlow Condensed" pitchFamily="34" charset="0"/>
+                <a:ea typeface="Barlow Condensed" pitchFamily="34" charset="-122"/>
+                <a:cs typeface="Barlow Condensed" pitchFamily="34" charset="-120"/>
+              </a:rPr>
+              <a:t>TECHNICAL DECISION</a:t>
+            </a:r>
+            <a:endParaRPr lang="en-US" sz="3400" dirty="0"/>
+          </a:p>
+        </p:txBody>
+      </p:sp>
+      <p:sp>
+        <p:nvSpPr>
+          <p:cNvPr id="10" name="Text 8"/>
+          <p:cNvSpPr/>
+          <p:nvPr/>
+        </p:nvSpPr>
+        <p:spPr>
+          <a:xfrm>
+            <a:off x="457200" y="1600200"/>
+            <a:ext cx="8961120" cy="411480"/>
+          </a:xfrm>
+          <a:prstGeom prst="rect">
+            <a:avLst/>
+          </a:prstGeom>
+          <a:noFill/>
+          <a:ln/>
+        </p:spPr>
+        <p:txBody>
+          <a:bodyPr wrap="square" rtlCol="0" anchor="t"/>
+          <a:lstStyle/>
+          <a:p>
+            <a:pPr indent="0" marL="0">
+              <a:buNone/>
+            </a:pPr>
+            <a:r>
+              <a:rPr lang="en-US" sz="1800" dirty="0">
+                <a:solidFill>
+                  <a:srgbClr val="6B6B6B"/>
+                </a:solidFill>
+                <a:latin typeface="Barlow" pitchFamily="34" charset="0"/>
+                <a:ea typeface="Barlow" pitchFamily="34" charset="-122"/>
+                <a:cs typeface="Barlow" pitchFamily="34" charset="-120"/>
+              </a:rPr>
+              <a:t>Frame rationale clearly: problem, constraints, decision, and trade-offs.</a:t>
+            </a:r>
+            <a:endParaRPr lang="en-US" sz="1800" dirty="0"/>
+          </a:p>
+        </p:txBody>
+      </p:sp>
+      <p:sp>
+        <p:nvSpPr>
+          <p:cNvPr id="11" name="Shape 9"/>
+          <p:cNvSpPr/>
+          <p:nvPr/>
+        </p:nvSpPr>
+        <p:spPr>
+          <a:xfrm>
+            <a:off x="457200" y="2057400"/>
+            <a:ext cx="11277295" cy="4206240"/>
+          </a:xfrm>
+          <a:prstGeom prst="roundRect">
+            <a:avLst>
+              <a:gd name="adj" fmla="val 2174"/>
+            </a:avLst>
+          </a:prstGeom>
+          <a:solidFill>
+            <a:srgbClr val="FFFAF4"/>
+          </a:solidFill>
+          <a:ln w="12700">
+            <a:solidFill>
+              <a:srgbClr val="D8C5AE"/>
+            </a:solidFill>
+            <a:prstDash val="solid"/>
+          </a:ln>
+        </p:spPr>
+      </p:sp>
+      <p:sp>
+        <p:nvSpPr>
+          <p:cNvPr id="12" name="Shape 10"/>
+          <p:cNvSpPr/>
+          <p:nvPr/>
+        </p:nvSpPr>
+        <p:spPr>
+          <a:xfrm>
+            <a:off x="457200" y="2057400"/>
+            <a:ext cx="128016" cy="4206240"/>
+          </a:xfrm>
+          <a:prstGeom prst="rect">
+            <a:avLst/>
+          </a:prstGeom>
+          <a:solidFill>
+            <a:srgbClr val="2A7D5B"/>
+          </a:solidFill>
+          <a:ln w="12700">
+            <a:solidFill>
+              <a:srgbClr val="2A7D5B"/>
+            </a:solidFill>
+            <a:prstDash val="solid"/>
+          </a:ln>
+        </p:spPr>
+      </p:sp>
+      <p:sp>
+        <p:nvSpPr>
+          <p:cNvPr id="13" name="Shape 11"/>
+          <p:cNvSpPr/>
+          <p:nvPr/>
+        </p:nvSpPr>
+        <p:spPr>
+          <a:xfrm>
+            <a:off x="749808" y="4114800"/>
+            <a:ext cx="10698480" cy="0"/>
+          </a:xfrm>
+          <a:prstGeom prst="line">
+            <a:avLst/>
+          </a:prstGeom>
+          <a:noFill/>
+          <a:ln w="12700">
+            <a:solidFill>
+              <a:srgbClr val="D8C5AE"/>
+            </a:solidFill>
+            <a:prstDash val="solid"/>
+          </a:ln>
+        </p:spPr>
+      </p:sp>
+      <p:sp>
+        <p:nvSpPr>
+          <p:cNvPr id="14" name="Shape 12"/>
+          <p:cNvSpPr/>
+          <p:nvPr/>
+        </p:nvSpPr>
+        <p:spPr>
+          <a:xfrm>
+            <a:off x="5961888" y="2423160"/>
+            <a:ext cx="0" cy="3611880"/>
+          </a:xfrm>
+          <a:prstGeom prst="line">
+            <a:avLst/>
+          </a:prstGeom>
+          <a:noFill/>
+          <a:ln w="12700">
+            <a:solidFill>
+              <a:srgbClr val="D8C5AE"/>
+            </a:solidFill>
+            <a:prstDash val="solid"/>
+          </a:ln>
+        </p:spPr>
+      </p:sp>
+      <p:sp>
+        <p:nvSpPr>
+          <p:cNvPr id="15" name="Text 13"/>
+          <p:cNvSpPr/>
+          <p:nvPr/>
+        </p:nvSpPr>
+        <p:spPr>
+          <a:xfrm>
+            <a:off x="841248" y="2468880"/>
+            <a:ext cx="4846320" cy="274320"/>
+          </a:xfrm>
+          <a:prstGeom prst="rect">
+            <a:avLst/>
+          </a:prstGeom>
+          <a:noFill/>
+          <a:ln/>
+        </p:spPr>
+        <p:txBody>
+          <a:bodyPr wrap="square" rtlCol="0" anchor="ctr"/>
+          <a:lstStyle/>
+          <a:p>
+            <a:pPr indent="0" marL="0">
+              <a:buNone/>
+            </a:pPr>
+            <a:r>
+              <a:rPr lang="en-US" sz="1400" b="1" dirty="0">
+                <a:solidFill>
+                  <a:srgbClr val="E8006A"/>
+                </a:solidFill>
+                <a:latin typeface="Barlow Condensed" pitchFamily="34" charset="0"/>
+                <a:ea typeface="Barlow Condensed" pitchFamily="34" charset="-122"/>
+                <a:cs typeface="Barlow Condensed" pitchFamily="34" charset="-120"/>
+              </a:rPr>
+              <a:t>01  PROBLEM</a:t>
+            </a:r>
+            <a:endParaRPr lang="en-US" sz="1400" dirty="0"/>
+          </a:p>
+        </p:txBody>
+      </p:sp>
+      <p:sp>
+        <p:nvSpPr>
+          <p:cNvPr id="16" name="Text 14"/>
+          <p:cNvSpPr/>
+          <p:nvPr/>
+        </p:nvSpPr>
+        <p:spPr>
+          <a:xfrm>
+            <a:off x="841248" y="2788920"/>
+            <a:ext cx="4846320" cy="1005840"/>
+          </a:xfrm>
+          <a:prstGeom prst="rect">
+            <a:avLst/>
+          </a:prstGeom>
+          <a:noFill/>
+          <a:ln/>
+        </p:spPr>
+        <p:txBody>
+          <a:bodyPr wrap="square" rtlCol="0" anchor="t"/>
+          <a:lstStyle/>
+          <a:p>
+            <a:pPr indent="0" marL="0">
+              <a:buNone/>
+            </a:pPr>
+            <a:r>
+              <a:rPr lang="en-US" sz="1600" dirty="0">
+                <a:solidFill>
+                  <a:srgbClr val="0F0F0F"/>
+                </a:solidFill>
+                <a:latin typeface="Barlow" pitchFamily="34" charset="0"/>
+                <a:ea typeface="Barlow" pitchFamily="34" charset="-122"/>
+                <a:cs typeface="Barlow" pitchFamily="34" charset="-120"/>
+              </a:rPr>
+              <a:t>What is failing, slow, or expensive today?</a:t>
+            </a:r>
+            <a:endParaRPr lang="en-US" sz="1600" dirty="0"/>
+          </a:p>
+        </p:txBody>
+      </p:sp>
+      <p:sp>
+        <p:nvSpPr>
+          <p:cNvPr id="17" name="Text 15"/>
+          <p:cNvSpPr/>
+          <p:nvPr/>
+        </p:nvSpPr>
+        <p:spPr>
+          <a:xfrm>
+            <a:off x="6254496" y="2468880"/>
+            <a:ext cx="4846320" cy="274320"/>
+          </a:xfrm>
+          <a:prstGeom prst="rect">
+            <a:avLst/>
+          </a:prstGeom>
+          <a:noFill/>
+          <a:ln/>
+        </p:spPr>
+        <p:txBody>
+          <a:bodyPr wrap="square" rtlCol="0" anchor="ctr"/>
+          <a:lstStyle/>
+          <a:p>
+            <a:pPr indent="0" marL="0">
+              <a:buNone/>
+            </a:pPr>
+            <a:r>
+              <a:rPr lang="en-US" sz="1400" b="1" dirty="0">
+                <a:solidFill>
+                  <a:srgbClr val="1B5A40"/>
+                </a:solidFill>
+                <a:latin typeface="Barlow Condensed" pitchFamily="34" charset="0"/>
+                <a:ea typeface="Barlow Condensed" pitchFamily="34" charset="-122"/>
+                <a:cs typeface="Barlow Condensed" pitchFamily="34" charset="-120"/>
+              </a:rPr>
+              <a:t>02  CONSTRAINTS</a:t>
+            </a:r>
+            <a:endParaRPr lang="en-US" sz="1400" dirty="0"/>
+          </a:p>
+        </p:txBody>
+      </p:sp>
+      <p:sp>
+        <p:nvSpPr>
+          <p:cNvPr id="18" name="Text 16"/>
+          <p:cNvSpPr/>
+          <p:nvPr/>
+        </p:nvSpPr>
+        <p:spPr>
+          <a:xfrm>
+            <a:off x="6254496" y="2788920"/>
+            <a:ext cx="4846320" cy="1005840"/>
+          </a:xfrm>
+          <a:prstGeom prst="rect">
+            <a:avLst/>
+          </a:prstGeom>
+          <a:noFill/>
+          <a:ln/>
+        </p:spPr>
+        <p:txBody>
+          <a:bodyPr wrap="square" rtlCol="0" anchor="t"/>
+          <a:lstStyle/>
+          <a:p>
+            <a:pPr indent="0" marL="0">
+              <a:buNone/>
+            </a:pPr>
+            <a:r>
+              <a:rPr lang="en-US" sz="1600" dirty="0">
+                <a:solidFill>
+                  <a:srgbClr val="0F0F0F"/>
+                </a:solidFill>
+                <a:latin typeface="Barlow" pitchFamily="34" charset="0"/>
+                <a:ea typeface="Barlow" pitchFamily="34" charset="-122"/>
+                <a:cs typeface="Barlow" pitchFamily="34" charset="-120"/>
+              </a:rPr>
+              <a:t>Latency, cost, team bandwidth, risk, and deadlines.</a:t>
+            </a:r>
+            <a:endParaRPr lang="en-US" sz="1600" dirty="0"/>
+          </a:p>
+        </p:txBody>
+      </p:sp>
+      <p:sp>
+        <p:nvSpPr>
+          <p:cNvPr id="19" name="Text 17"/>
+          <p:cNvSpPr/>
+          <p:nvPr/>
+        </p:nvSpPr>
+        <p:spPr>
+          <a:xfrm>
+            <a:off x="841248" y="4389120"/>
+            <a:ext cx="4846320" cy="274320"/>
+          </a:xfrm>
+          <a:prstGeom prst="rect">
+            <a:avLst/>
+          </a:prstGeom>
+          <a:noFill/>
+          <a:ln/>
+        </p:spPr>
+        <p:txBody>
+          <a:bodyPr wrap="square" rtlCol="0" anchor="ctr"/>
+          <a:lstStyle/>
+          <a:p>
+            <a:pPr indent="0" marL="0">
+              <a:buNone/>
+            </a:pPr>
+            <a:r>
+              <a:rPr lang="en-US" sz="1400" b="1" dirty="0">
+                <a:solidFill>
+                  <a:srgbClr val="2A7D5B"/>
+                </a:solidFill>
+                <a:latin typeface="Barlow Condensed" pitchFamily="34" charset="0"/>
+                <a:ea typeface="Barlow Condensed" pitchFamily="34" charset="-122"/>
+                <a:cs typeface="Barlow Condensed" pitchFamily="34" charset="-120"/>
+              </a:rPr>
+              <a:t>03  DECISION</a:t>
+            </a:r>
+            <a:endParaRPr lang="en-US" sz="1400" dirty="0"/>
+          </a:p>
+        </p:txBody>
+      </p:sp>
+      <p:sp>
+        <p:nvSpPr>
+          <p:cNvPr id="20" name="Text 18"/>
+          <p:cNvSpPr/>
+          <p:nvPr/>
+        </p:nvSpPr>
+        <p:spPr>
+          <a:xfrm>
+            <a:off x="841248" y="4709160"/>
+            <a:ext cx="4846320" cy="1005840"/>
+          </a:xfrm>
+          <a:prstGeom prst="rect">
+            <a:avLst/>
+          </a:prstGeom>
+          <a:noFill/>
+          <a:ln/>
+        </p:spPr>
+        <p:txBody>
+          <a:bodyPr wrap="square" rtlCol="0" anchor="t"/>
+          <a:lstStyle/>
+          <a:p>
+            <a:pPr indent="0" marL="0">
+              <a:buNone/>
+            </a:pPr>
+            <a:r>
+              <a:rPr lang="en-US" sz="1600" dirty="0">
+                <a:solidFill>
+                  <a:srgbClr val="0F0F0F"/>
+                </a:solidFill>
+                <a:latin typeface="Barlow" pitchFamily="34" charset="0"/>
+                <a:ea typeface="Barlow" pitchFamily="34" charset="-122"/>
+                <a:cs typeface="Barlow" pitchFamily="34" charset="-120"/>
+              </a:rPr>
+              <a:t>State the chosen approach in one sentence.</a:t>
+            </a:r>
+            <a:endParaRPr lang="en-US" sz="1600" dirty="0"/>
+          </a:p>
+        </p:txBody>
+      </p:sp>
+      <p:sp>
+        <p:nvSpPr>
+          <p:cNvPr id="21" name="Text 19"/>
+          <p:cNvSpPr/>
+          <p:nvPr/>
+        </p:nvSpPr>
+        <p:spPr>
+          <a:xfrm>
+            <a:off x="6254496" y="4389120"/>
+            <a:ext cx="4846320" cy="274320"/>
+          </a:xfrm>
+          <a:prstGeom prst="rect">
+            <a:avLst/>
+          </a:prstGeom>
+          <a:noFill/>
+          <a:ln/>
+        </p:spPr>
+        <p:txBody>
+          <a:bodyPr wrap="square" rtlCol="0" anchor="ctr"/>
+          <a:lstStyle/>
+          <a:p>
+            <a:pPr indent="0" marL="0">
+              <a:buNone/>
+            </a:pPr>
+            <a:r>
+              <a:rPr lang="en-US" sz="1400" b="1" dirty="0">
+                <a:solidFill>
+                  <a:srgbClr val="E8006A"/>
+                </a:solidFill>
+                <a:latin typeface="Barlow Condensed" pitchFamily="34" charset="0"/>
+                <a:ea typeface="Barlow Condensed" pitchFamily="34" charset="-122"/>
+                <a:cs typeface="Barlow Condensed" pitchFamily="34" charset="-120"/>
+              </a:rPr>
+              <a:t>04  TRADE-OFFS</a:t>
+            </a:r>
+            <a:endParaRPr lang="en-US" sz="1400" dirty="0"/>
+          </a:p>
+        </p:txBody>
+      </p:sp>
+      <p:sp>
+        <p:nvSpPr>
+          <p:cNvPr id="22" name="Text 20"/>
+          <p:cNvSpPr/>
+          <p:nvPr/>
+        </p:nvSpPr>
+        <p:spPr>
+          <a:xfrm>
+            <a:off x="6254496" y="4709160"/>
+            <a:ext cx="4846320" cy="1005840"/>
+          </a:xfrm>
+          <a:prstGeom prst="rect">
+            <a:avLst/>
+          </a:prstGeom>
+          <a:noFill/>
+          <a:ln/>
+        </p:spPr>
+        <p:txBody>
+          <a:bodyPr wrap="square" rtlCol="0" anchor="t"/>
+          <a:lstStyle/>
+          <a:p>
+            <a:pPr indent="0" marL="0">
+              <a:buNone/>
+            </a:pPr>
+            <a:r>
+              <a:rPr lang="en-US" sz="1600" dirty="0">
+                <a:solidFill>
+                  <a:srgbClr val="0F0F0F"/>
+                </a:solidFill>
+                <a:latin typeface="Barlow" pitchFamily="34" charset="0"/>
+                <a:ea typeface="Barlow" pitchFamily="34" charset="-122"/>
+                <a:cs typeface="Barlow" pitchFamily="34" charset="-120"/>
+              </a:rPr>
+              <a:t>What you gained, what you gave up, and why it is acceptable.</a:t>
+            </a:r>
+            <a:endParaRPr lang="en-US" sz="1600" dirty="0"/>
+          </a:p>
+        </p:txBody>
+      </p:sp>
+      <p:sp>
+        <p:nvSpPr>
+          <p:cNvPr id="23" name="Shape 21"/>
+          <p:cNvSpPr/>
+          <p:nvPr/>
+        </p:nvSpPr>
+        <p:spPr>
+          <a:xfrm>
+            <a:off x="457200" y="6446520"/>
+            <a:ext cx="11277295" cy="0"/>
+          </a:xfrm>
+          <a:prstGeom prst="line">
+            <a:avLst/>
+          </a:prstGeom>
+          <a:noFill/>
+          <a:ln w="12700">
+            <a:solidFill>
+              <a:srgbClr val="D7D7D7"/>
+            </a:solidFill>
+            <a:prstDash val="solid"/>
+          </a:ln>
+        </p:spPr>
+      </p:sp>
+      <p:sp>
+        <p:nvSpPr>
+          <p:cNvPr id="24" name="Text 22"/>
+          <p:cNvSpPr/>
+          <p:nvPr/>
+        </p:nvSpPr>
+        <p:spPr>
+          <a:xfrm>
+            <a:off x="457200" y="6473952"/>
+            <a:ext cx="3657600" cy="182880"/>
+          </a:xfrm>
+          <a:prstGeom prst="rect">
+            <a:avLst/>
+          </a:prstGeom>
+          <a:noFill/>
+          <a:ln/>
+        </p:spPr>
+        <p:txBody>
+          <a:bodyPr wrap="square" rtlCol="0" anchor="ctr"/>
+          <a:lstStyle/>
+          <a:p>
+            <a:pPr indent="0" marL="0">
+              <a:buNone/>
+            </a:pPr>
+            <a:r>
+              <a:rPr lang="en-US" sz="1000" dirty="0">
+                <a:solidFill>
+                  <a:srgbClr val="6B6B6B"/>
+                </a:solidFill>
+                <a:latin typeface="Barlow" pitchFamily="34" charset="0"/>
+                <a:ea typeface="Barlow" pitchFamily="34" charset="-122"/>
+                <a:cs typeface="Barlow" pitchFamily="34" charset="-120"/>
+              </a:rPr>
+              <a:t>sourcier.uk</a:t>
+            </a:r>
+            <a:endParaRPr lang="en-US" sz="1000" dirty="0"/>
+          </a:p>
+        </p:txBody>
+      </p:sp>
+      <p:sp>
+        <p:nvSpPr>
+          <p:cNvPr id="25" name="Text 23"/>
+          <p:cNvSpPr/>
+          <p:nvPr/>
+        </p:nvSpPr>
+        <p:spPr>
+          <a:xfrm>
+            <a:off x="10744200" y="6473952"/>
+            <a:ext cx="1005840" cy="182880"/>
+          </a:xfrm>
+          <a:prstGeom prst="rect">
+            <a:avLst/>
+          </a:prstGeom>
+          <a:noFill/>
+          <a:ln/>
+        </p:spPr>
+        <p:txBody>
+          <a:bodyPr wrap="square" rtlCol="0" anchor="ctr"/>
+          <a:lstStyle/>
+          <a:p>
+            <a:pPr algn="r" indent="0" marL="0">
+              <a:buNone/>
+            </a:pPr>
+            <a:r>
+              <a:rPr lang="en-US" sz="1000" dirty="0">
+                <a:solidFill>
+                  <a:srgbClr val="6B6B6B"/>
+                </a:solidFill>
+                <a:latin typeface="Barlow" pitchFamily="34" charset="0"/>
+                <a:ea typeface="Barlow" pitchFamily="34" charset="-122"/>
+                <a:cs typeface="Barlow" pitchFamily="34" charset="-120"/>
+              </a:rPr>
+              <a:t>[slide number]</a:t>
+            </a:r>
+            <a:endParaRPr lang="en-US" sz="1000" dirty="0"/>
+          </a:p>
+        </p:txBody>
+      </p:sp>
+    </p:spTree>
+  </p:cSld>
+  <p:clrMapOvr>
+    <a:masterClrMapping/>
+  </p:clrMapOvr>
+</p:sld>
+</file>
+
+<file path=ppt/slides/slide7.xml><?xml version="1.0" encoding="utf-8"?>
+<p:sld xmlns:a="http://schemas.openxmlformats.org/drawingml/2006/main" xmlns:r="http://schemas.openxmlformats.org/officeDocument/2006/relationships" xmlns:p="http://schemas.openxmlformats.org/presentationml/2006/main">
+  <p:cSld name="Slide 7">
+    <p:bg>
+      <p:bgPr>
+        <a:solidFill>
+          <a:srgbClr val="F6ECE1"/>
+        </a:solidFill>
+      </p:bgPr>
+    </p:bg>
+    <p:spTree>
+      <p:nvGrpSpPr>
+        <p:cNvPr id="1" name=""/>
+        <p:cNvGrpSpPr/>
+        <p:nvPr/>
+      </p:nvGrpSpPr>
+      <p:grpSpPr>
+        <a:xfrm>
+          <a:off x="0" y="0"/>
+          <a:ext cx="0" cy="0"/>
+          <a:chOff x="0" y="0"/>
+          <a:chExt cx="0" cy="0"/>
+        </a:xfrm>
+      </p:grpSpPr>
+      <p:sp>
+        <p:nvSpPr>
+          <p:cNvPr id="2" name="Shape 0"/>
+          <p:cNvSpPr/>
+          <p:nvPr/>
+        </p:nvSpPr>
+        <p:spPr>
+          <a:xfrm>
+            <a:off x="-1920240" y="-1097280"/>
+            <a:ext cx="5394960" cy="4480560"/>
+          </a:xfrm>
+          <a:prstGeom prst="roundRect">
+            <a:avLst>
+              <a:gd name="adj" fmla="val 6122"/>
+            </a:avLst>
+          </a:prstGeom>
+          <a:solidFill>
+            <a:srgbClr val="E8006A">
+              <a:alpha val="8000"/>
+            </a:srgbClr>
+          </a:solidFill>
+          <a:ln w="12700">
+            <a:solidFill>
+              <a:srgbClr val="E8006A">
+                <a:alpha val="0"/>
+              </a:srgbClr>
+            </a:solidFill>
+            <a:prstDash val="solid"/>
+          </a:ln>
+        </p:spPr>
+      </p:sp>
+      <p:sp>
+        <p:nvSpPr>
+          <p:cNvPr id="3" name="Shape 1"/>
+          <p:cNvSpPr/>
+          <p:nvPr/>
+        </p:nvSpPr>
+        <p:spPr>
+          <a:xfrm>
+            <a:off x="8412480" y="-1371600"/>
+            <a:ext cx="5669280" cy="5120640"/>
+          </a:xfrm>
+          <a:prstGeom prst="roundRect">
+            <a:avLst>
+              <a:gd name="adj" fmla="val 5357"/>
+            </a:avLst>
+          </a:prstGeom>
+          <a:solidFill>
+            <a:srgbClr val="2A7D5B">
+              <a:alpha val="10000"/>
+            </a:srgbClr>
+          </a:solidFill>
+          <a:ln w="12700">
+            <a:solidFill>
+              <a:srgbClr val="2A7D5B">
+                <a:alpha val="0"/>
+              </a:srgbClr>
+            </a:solidFill>
+            <a:prstDash val="solid"/>
+          </a:ln>
+        </p:spPr>
+      </p:sp>
+      <p:sp>
+        <p:nvSpPr>
+          <p:cNvPr id="4" name="Shape 2"/>
+          <p:cNvSpPr/>
+          <p:nvPr/>
+        </p:nvSpPr>
+        <p:spPr>
+          <a:xfrm>
+            <a:off x="6492240" y="5029200"/>
+            <a:ext cx="7406640" cy="3108960"/>
+          </a:xfrm>
+          <a:prstGeom prst="roundRect">
+            <a:avLst>
+              <a:gd name="adj" fmla="val 8824"/>
+            </a:avLst>
+          </a:prstGeom>
+          <a:solidFill>
+            <a:srgbClr val="E5D8C9">
+              <a:alpha val="76000"/>
+            </a:srgbClr>
+          </a:solidFill>
+          <a:ln w="12700">
+            <a:solidFill>
+              <a:srgbClr val="E5D8C9">
+                <a:alpha val="0"/>
+              </a:srgbClr>
+            </a:solidFill>
+            <a:prstDash val="solid"/>
+          </a:ln>
+        </p:spPr>
+      </p:sp>
+      <p:sp>
+        <p:nvSpPr>
+          <p:cNvPr id="5" name="Shape 3"/>
+          <p:cNvSpPr/>
+          <p:nvPr/>
+        </p:nvSpPr>
+        <p:spPr>
+          <a:xfrm>
+            <a:off x="0" y="0"/>
+            <a:ext cx="12191695" cy="658368"/>
+          </a:xfrm>
+          <a:prstGeom prst="rect">
+            <a:avLst/>
+          </a:prstGeom>
+          <a:solidFill>
+            <a:srgbClr val="101410"/>
+          </a:solidFill>
+          <a:ln w="12700">
+            <a:solidFill>
+              <a:srgbClr val="101410"/>
+            </a:solidFill>
+            <a:prstDash val="solid"/>
+          </a:ln>
+        </p:spPr>
+      </p:sp>
+      <p:sp>
+        <p:nvSpPr>
+          <p:cNvPr id="6" name="Shape 4"/>
+          <p:cNvSpPr/>
+          <p:nvPr/>
+        </p:nvSpPr>
+        <p:spPr>
+          <a:xfrm>
+            <a:off x="0" y="658368"/>
+            <a:ext cx="12191695" cy="0"/>
+          </a:xfrm>
+          <a:prstGeom prst="line">
+            <a:avLst/>
+          </a:prstGeom>
+          <a:noFill/>
+          <a:ln w="12700">
+            <a:solidFill>
+              <a:srgbClr val="E8006A"/>
+            </a:solidFill>
+            <a:prstDash val="solid"/>
+          </a:ln>
+        </p:spPr>
+      </p:sp>
+      <p:sp>
+        <p:nvSpPr>
+          <p:cNvPr id="7" name="Shape 5"/>
+          <p:cNvSpPr/>
+          <p:nvPr/>
+        </p:nvSpPr>
+        <p:spPr>
+          <a:xfrm>
+            <a:off x="0" y="621792"/>
+            <a:ext cx="12191695" cy="0"/>
+          </a:xfrm>
+          <a:prstGeom prst="line">
+            <a:avLst/>
+          </a:prstGeom>
+          <a:noFill/>
+          <a:ln w="12700">
+            <a:solidFill>
+              <a:srgbClr val="2A7D5B">
+                <a:alpha val="76000"/>
+              </a:srgbClr>
+            </a:solidFill>
+            <a:prstDash val="solid"/>
+          </a:ln>
+        </p:spPr>
+      </p:sp>
+      <p:sp>
+        <p:nvSpPr>
+          <p:cNvPr id="8" name="Text 6"/>
+          <p:cNvSpPr/>
+          <p:nvPr/>
+        </p:nvSpPr>
+        <p:spPr>
+          <a:xfrm>
+            <a:off x="457200" y="155448"/>
+            <a:ext cx="2560320" cy="274320"/>
+          </a:xfrm>
+          <a:prstGeom prst="rect">
+            <a:avLst/>
+          </a:prstGeom>
+          <a:noFill/>
+          <a:ln/>
+        </p:spPr>
+        <p:txBody>
+          <a:bodyPr wrap="square" rtlCol="0" anchor="ctr"/>
+          <a:lstStyle/>
+          <a:p>
+            <a:pPr indent="0" marL="0">
+              <a:buNone/>
+            </a:pPr>
+            <a:r>
+              <a:rPr lang="en-US" sz="1800" b="1" dirty="0">
+                <a:solidFill>
+                  <a:srgbClr val="FFFFFF"/>
+                </a:solidFill>
+                <a:latin typeface="Barlow Condensed" pitchFamily="34" charset="0"/>
+                <a:ea typeface="Barlow Condensed" pitchFamily="34" charset="-122"/>
+                <a:cs typeface="Barlow Condensed" pitchFamily="34" charset="-120"/>
+              </a:rPr>
+              <a:t>SOURCIER</a:t>
+            </a:r>
+            <a:endParaRPr lang="en-US" sz="1800" dirty="0"/>
+          </a:p>
+        </p:txBody>
+      </p:sp>
+      <p:sp>
+        <p:nvSpPr>
+          <p:cNvPr id="9" name="Text 7"/>
+          <p:cNvSpPr/>
+          <p:nvPr/>
+        </p:nvSpPr>
+        <p:spPr>
+          <a:xfrm>
+            <a:off x="457200" y="914400"/>
+            <a:ext cx="7863840" cy="685800"/>
+          </a:xfrm>
+          <a:prstGeom prst="rect">
+            <a:avLst/>
+          </a:prstGeom>
+          <a:noFill/>
+          <a:ln/>
+        </p:spPr>
+        <p:txBody>
+          <a:bodyPr wrap="square" rtlCol="0" anchor="ctr">
+            <a:normAutofit/>
+          </a:bodyPr>
+          <a:lstStyle/>
+          <a:p>
+            <a:pPr indent="0" marL="0">
+              <a:buNone/>
+            </a:pPr>
+            <a:r>
+              <a:rPr lang="en-US" sz="3400" b="1" dirty="0">
+                <a:solidFill>
+                  <a:srgbClr val="0F0F0F"/>
+                </a:solidFill>
+                <a:latin typeface="Barlow Condensed" pitchFamily="34" charset="0"/>
+                <a:ea typeface="Barlow Condensed" pitchFamily="34" charset="-122"/>
+                <a:cs typeface="Barlow Condensed" pitchFamily="34" charset="-120"/>
+              </a:rPr>
+              <a:t>QUOTE LAYOUT</a:t>
+            </a:r>
+            <a:endParaRPr lang="en-US" sz="3400" dirty="0"/>
+          </a:p>
+        </p:txBody>
+      </p:sp>
+      <p:sp>
+        <p:nvSpPr>
+          <p:cNvPr id="10" name="Text 8"/>
+          <p:cNvSpPr/>
+          <p:nvPr/>
+        </p:nvSpPr>
+        <p:spPr>
+          <a:xfrm>
+            <a:off x="457200" y="1600200"/>
+            <a:ext cx="8961120" cy="411480"/>
+          </a:xfrm>
+          <a:prstGeom prst="rect">
+            <a:avLst/>
+          </a:prstGeom>
+          <a:noFill/>
+          <a:ln/>
+        </p:spPr>
+        <p:txBody>
+          <a:bodyPr wrap="square" rtlCol="0" anchor="t"/>
+          <a:lstStyle/>
+          <a:p>
+            <a:pPr indent="0" marL="0">
+              <a:buNone/>
+            </a:pPr>
+            <a:r>
+              <a:rPr lang="en-US" sz="1800" dirty="0">
+                <a:solidFill>
+                  <a:srgbClr val="6B6B6B"/>
+                </a:solidFill>
+                <a:latin typeface="Barlow" pitchFamily="34" charset="0"/>
+                <a:ea typeface="Barlow" pitchFamily="34" charset="-122"/>
+                <a:cs typeface="Barlow" pitchFamily="34" charset="-120"/>
+              </a:rPr>
+              <a:t>Ideal for key takeaways and narrative pivots.</a:t>
+            </a:r>
+            <a:endParaRPr lang="en-US" sz="1800" dirty="0"/>
+          </a:p>
+        </p:txBody>
+      </p:sp>
+      <p:sp>
+        <p:nvSpPr>
+          <p:cNvPr id="11" name="Shape 9"/>
+          <p:cNvSpPr/>
+          <p:nvPr/>
+        </p:nvSpPr>
+        <p:spPr>
+          <a:xfrm>
+            <a:off x="1143000" y="2240280"/>
+            <a:ext cx="9921240" cy="3063240"/>
+          </a:xfrm>
+          <a:prstGeom prst="roundRect">
+            <a:avLst>
+              <a:gd name="adj" fmla="val 2985"/>
+            </a:avLst>
+          </a:prstGeom>
+          <a:solidFill>
+            <a:srgbClr val="FFFAF4"/>
+          </a:solidFill>
+          <a:ln w="12700">
+            <a:solidFill>
+              <a:srgbClr val="E8006A"/>
+            </a:solidFill>
+            <a:prstDash val="solid"/>
+          </a:ln>
+        </p:spPr>
+      </p:sp>
+      <p:sp>
+        <p:nvSpPr>
+          <p:cNvPr id="12" name="Shape 10"/>
+          <p:cNvSpPr/>
+          <p:nvPr/>
+        </p:nvSpPr>
+        <p:spPr>
+          <a:xfrm>
+            <a:off x="1143000" y="2240280"/>
+            <a:ext cx="128016" cy="3063240"/>
+          </a:xfrm>
+          <a:prstGeom prst="rect">
+            <a:avLst/>
+          </a:prstGeom>
+          <a:solidFill>
+            <a:srgbClr val="2A7D5B"/>
+          </a:solidFill>
+          <a:ln w="12700">
+            <a:solidFill>
+              <a:srgbClr val="2A7D5B"/>
+            </a:solidFill>
+            <a:prstDash val="solid"/>
+          </a:ln>
+        </p:spPr>
+      </p:sp>
+      <p:sp>
+        <p:nvSpPr>
+          <p:cNvPr id="13" name="Text 11"/>
+          <p:cNvSpPr/>
+          <p:nvPr/>
+        </p:nvSpPr>
+        <p:spPr>
+          <a:xfrm>
+            <a:off x="1554480" y="2468880"/>
+            <a:ext cx="822960" cy="640080"/>
+          </a:xfrm>
+          <a:prstGeom prst="rect">
+            <a:avLst/>
+          </a:prstGeom>
+          <a:noFill/>
+          <a:ln/>
+        </p:spPr>
+        <p:txBody>
+          <a:bodyPr wrap="square" rtlCol="0" anchor="ctr"/>
+          <a:lstStyle/>
+          <a:p>
+            <a:pPr indent="0" marL="0">
+              <a:buNone/>
+            </a:pPr>
+            <a:r>
+              <a:rPr lang="en-US" sz="7200" dirty="0">
+                <a:solidFill>
+                  <a:srgbClr val="E8006A"/>
+                </a:solidFill>
+                <a:latin typeface="Barlow Condensed" pitchFamily="34" charset="0"/>
+                <a:ea typeface="Barlow Condensed" pitchFamily="34" charset="-122"/>
+                <a:cs typeface="Barlow Condensed" pitchFamily="34" charset="-120"/>
+              </a:rPr>
+              <a:t>"</a:t>
+            </a:r>
+            <a:endParaRPr lang="en-US" sz="7200" dirty="0"/>
+          </a:p>
+        </p:txBody>
+      </p:sp>
+      <p:sp>
+        <p:nvSpPr>
+          <p:cNvPr id="14" name="Text 12"/>
+          <p:cNvSpPr/>
+          <p:nvPr/>
+        </p:nvSpPr>
+        <p:spPr>
+          <a:xfrm>
+            <a:off x="2194560" y="3017520"/>
+            <a:ext cx="8138160" cy="1280160"/>
+          </a:xfrm>
+          <a:prstGeom prst="rect">
+            <a:avLst/>
+          </a:prstGeom>
+          <a:noFill/>
+          <a:ln/>
+        </p:spPr>
+        <p:txBody>
+          <a:bodyPr wrap="square" rtlCol="0" anchor="ctr">
+            <a:normAutofit/>
+          </a:bodyPr>
+          <a:lstStyle/>
+          <a:p>
+            <a:pPr algn="ctr" indent="0" marL="0">
+              <a:buNone/>
+            </a:pPr>
+            <a:r>
+              <a:rPr lang="en-US" sz="2700" i="1" dirty="0">
+                <a:solidFill>
+                  <a:srgbClr val="0F0F0F"/>
+                </a:solidFill>
+                <a:latin typeface="Barlow" pitchFamily="34" charset="0"/>
+                <a:ea typeface="Barlow" pitchFamily="34" charset="-122"/>
+                <a:cs typeface="Barlow" pitchFamily="34" charset="-120"/>
+              </a:rPr>
+              <a:t>Replace with a strong insight, user quote, or key lesson from the project.</a:t>
+            </a:r>
+            <a:endParaRPr lang="en-US" sz="2700" dirty="0"/>
+          </a:p>
+        </p:txBody>
+      </p:sp>
+      <p:sp>
+        <p:nvSpPr>
+          <p:cNvPr id="15" name="Text 13"/>
+          <p:cNvSpPr/>
+          <p:nvPr/>
+        </p:nvSpPr>
+        <p:spPr>
+          <a:xfrm>
+            <a:off x="2194560" y="4681728"/>
+            <a:ext cx="8138160" cy="274320"/>
+          </a:xfrm>
+          <a:prstGeom prst="rect">
+            <a:avLst/>
+          </a:prstGeom>
+          <a:noFill/>
+          <a:ln/>
+        </p:spPr>
+        <p:txBody>
+          <a:bodyPr wrap="square" rtlCol="0" anchor="ctr"/>
+          <a:lstStyle/>
+          <a:p>
+            <a:pPr algn="ctr" indent="0" marL="0">
+              <a:buNone/>
+            </a:pPr>
+            <a:r>
+              <a:rPr lang="en-US" sz="1400" dirty="0">
+                <a:solidFill>
+                  <a:srgbClr val="6B6B6B"/>
+                </a:solidFill>
+                <a:latin typeface="Barlow" pitchFamily="34" charset="0"/>
+                <a:ea typeface="Barlow" pitchFamily="34" charset="-122"/>
+                <a:cs typeface="Barlow" pitchFamily="34" charset="-120"/>
+              </a:rPr>
+              <a:t>Attribution / Source</a:t>
+            </a:r>
+            <a:endParaRPr lang="en-US" sz="1400" dirty="0"/>
+          </a:p>
+        </p:txBody>
+      </p:sp>
+      <p:sp>
+        <p:nvSpPr>
+          <p:cNvPr id="16" name="Shape 14"/>
+          <p:cNvSpPr/>
+          <p:nvPr/>
+        </p:nvSpPr>
+        <p:spPr>
+          <a:xfrm>
+            <a:off x="457200" y="6446520"/>
+            <a:ext cx="11277295" cy="0"/>
+          </a:xfrm>
+          <a:prstGeom prst="line">
+            <a:avLst/>
+          </a:prstGeom>
+          <a:noFill/>
+          <a:ln w="12700">
+            <a:solidFill>
+              <a:srgbClr val="D7D7D7"/>
+            </a:solidFill>
+            <a:prstDash val="solid"/>
+          </a:ln>
+        </p:spPr>
+      </p:sp>
+      <p:sp>
+        <p:nvSpPr>
+          <p:cNvPr id="17" name="Text 15"/>
+          <p:cNvSpPr/>
+          <p:nvPr/>
+        </p:nvSpPr>
+        <p:spPr>
+          <a:xfrm>
+            <a:off x="457200" y="6473952"/>
+            <a:ext cx="3657600" cy="182880"/>
+          </a:xfrm>
+          <a:prstGeom prst="rect">
+            <a:avLst/>
+          </a:prstGeom>
+          <a:noFill/>
+          <a:ln/>
+        </p:spPr>
+        <p:txBody>
+          <a:bodyPr wrap="square" rtlCol="0" anchor="ctr"/>
+          <a:lstStyle/>
+          <a:p>
+            <a:pPr indent="0" marL="0">
+              <a:buNone/>
+            </a:pPr>
+            <a:r>
+              <a:rPr lang="en-US" sz="1000" dirty="0">
+                <a:solidFill>
+                  <a:srgbClr val="6B6B6B"/>
+                </a:solidFill>
+                <a:latin typeface="Barlow" pitchFamily="34" charset="0"/>
+                <a:ea typeface="Barlow" pitchFamily="34" charset="-122"/>
+                <a:cs typeface="Barlow" pitchFamily="34" charset="-120"/>
+              </a:rPr>
+              <a:t>sourcier.uk</a:t>
+            </a:r>
+            <a:endParaRPr lang="en-US" sz="1000" dirty="0"/>
+          </a:p>
+        </p:txBody>
+      </p:sp>
+      <p:sp>
+        <p:nvSpPr>
+          <p:cNvPr id="18" name="Text 16"/>
+          <p:cNvSpPr/>
+          <p:nvPr/>
+        </p:nvSpPr>
+        <p:spPr>
+          <a:xfrm>
+            <a:off x="10744200" y="6473952"/>
+            <a:ext cx="1005840" cy="182880"/>
+          </a:xfrm>
+          <a:prstGeom prst="rect">
+            <a:avLst/>
+          </a:prstGeom>
+          <a:noFill/>
+          <a:ln/>
+        </p:spPr>
+        <p:txBody>
+          <a:bodyPr wrap="square" rtlCol="0" anchor="ctr"/>
+          <a:lstStyle/>
+          <a:p>
+            <a:pPr algn="r" indent="0" marL="0">
+              <a:buNone/>
+            </a:pPr>
+            <a:r>
+              <a:rPr lang="en-US" sz="1000" dirty="0">
+                <a:solidFill>
+                  <a:srgbClr val="6B6B6B"/>
+                </a:solidFill>
+                <a:latin typeface="Barlow" pitchFamily="34" charset="0"/>
+                <a:ea typeface="Barlow" pitchFamily="34" charset="-122"/>
+                <a:cs typeface="Barlow" pitchFamily="34" charset="-120"/>
+              </a:rPr>
+              <a:t>[slide number]</a:t>
+            </a:r>
+            <a:endParaRPr lang="en-US" sz="1000" dirty="0"/>
+          </a:p>
+        </p:txBody>
+      </p:sp>
+    </p:spTree>
+  </p:cSld>
+  <p:clrMapOvr>
+    <a:masterClrMapping/>
+  </p:clrMapOvr>
+</p:sld>
+</file>
+
+<file path=ppt/slides/slide8.xml><?xml version="1.0" encoding="utf-8"?>
+<p:sld xmlns:a="http://schemas.openxmlformats.org/drawingml/2006/main" xmlns:r="http://schemas.openxmlformats.org/officeDocument/2006/relationships" xmlns:p="http://schemas.openxmlformats.org/presentationml/2006/main">
+  <p:cSld name="Slide 8">
+    <p:bg>
+      <p:bgPr>
+        <a:solidFill>
+          <a:srgbClr val="F6ECE1"/>
+        </a:solidFill>
+      </p:bgPr>
+    </p:bg>
+    <p:spTree>
+      <p:nvGrpSpPr>
+        <p:cNvPr id="1" name=""/>
+        <p:cNvGrpSpPr/>
+        <p:nvPr/>
+      </p:nvGrpSpPr>
+      <p:grpSpPr>
+        <a:xfrm>
+          <a:off x="0" y="0"/>
+          <a:ext cx="0" cy="0"/>
+          <a:chOff x="0" y="0"/>
+          <a:chExt cx="0" cy="0"/>
+        </a:xfrm>
+      </p:grpSpPr>
+      <p:sp>
+        <p:nvSpPr>
+          <p:cNvPr id="2" name="Shape 0"/>
+          <p:cNvSpPr/>
+          <p:nvPr/>
+        </p:nvSpPr>
+        <p:spPr>
+          <a:xfrm>
+            <a:off x="-1920240" y="-1097280"/>
+            <a:ext cx="5394960" cy="4480560"/>
+          </a:xfrm>
+          <a:prstGeom prst="roundRect">
+            <a:avLst>
+              <a:gd name="adj" fmla="val 6122"/>
+            </a:avLst>
+          </a:prstGeom>
+          <a:solidFill>
+            <a:srgbClr val="E8006A">
+              <a:alpha val="8000"/>
+            </a:srgbClr>
+          </a:solidFill>
+          <a:ln w="12700">
+            <a:solidFill>
+              <a:srgbClr val="E8006A">
+                <a:alpha val="0"/>
+              </a:srgbClr>
+            </a:solidFill>
+            <a:prstDash val="solid"/>
+          </a:ln>
+        </p:spPr>
+      </p:sp>
+      <p:sp>
+        <p:nvSpPr>
+          <p:cNvPr id="3" name="Shape 1"/>
+          <p:cNvSpPr/>
+          <p:nvPr/>
+        </p:nvSpPr>
+        <p:spPr>
+          <a:xfrm>
+            <a:off x="8412480" y="-1371600"/>
+            <a:ext cx="5669280" cy="5120640"/>
+          </a:xfrm>
+          <a:prstGeom prst="roundRect">
+            <a:avLst>
+              <a:gd name="adj" fmla="val 5357"/>
+            </a:avLst>
+          </a:prstGeom>
+          <a:solidFill>
+            <a:srgbClr val="2A7D5B">
+              <a:alpha val="10000"/>
+            </a:srgbClr>
+          </a:solidFill>
+          <a:ln w="12700">
+            <a:solidFill>
+              <a:srgbClr val="2A7D5B">
+                <a:alpha val="0"/>
+              </a:srgbClr>
+            </a:solidFill>
+            <a:prstDash val="solid"/>
+          </a:ln>
+        </p:spPr>
+      </p:sp>
+      <p:sp>
+        <p:nvSpPr>
+          <p:cNvPr id="4" name="Shape 2"/>
+          <p:cNvSpPr/>
+          <p:nvPr/>
+        </p:nvSpPr>
+        <p:spPr>
+          <a:xfrm>
+            <a:off x="6492240" y="5029200"/>
+            <a:ext cx="7406640" cy="3108960"/>
+          </a:xfrm>
+          <a:prstGeom prst="roundRect">
+            <a:avLst>
+              <a:gd name="adj" fmla="val 8824"/>
+            </a:avLst>
+          </a:prstGeom>
+          <a:solidFill>
+            <a:srgbClr val="E5D8C9">
+              <a:alpha val="76000"/>
+            </a:srgbClr>
+          </a:solidFill>
+          <a:ln w="12700">
+            <a:solidFill>
+              <a:srgbClr val="E5D8C9">
+                <a:alpha val="0"/>
+              </a:srgbClr>
+            </a:solidFill>
+            <a:prstDash val="solid"/>
+          </a:ln>
+        </p:spPr>
+      </p:sp>
+      <p:sp>
+        <p:nvSpPr>
+          <p:cNvPr id="5" name="Shape 3"/>
+          <p:cNvSpPr/>
+          <p:nvPr/>
+        </p:nvSpPr>
+        <p:spPr>
+          <a:xfrm>
+            <a:off x="0" y="0"/>
+            <a:ext cx="12191695" cy="658368"/>
+          </a:xfrm>
+          <a:prstGeom prst="rect">
+            <a:avLst/>
+          </a:prstGeom>
+          <a:solidFill>
+            <a:srgbClr val="101410"/>
+          </a:solidFill>
+          <a:ln w="12700">
+            <a:solidFill>
+              <a:srgbClr val="101410"/>
+            </a:solidFill>
+            <a:prstDash val="solid"/>
+          </a:ln>
+        </p:spPr>
+      </p:sp>
+      <p:sp>
+        <p:nvSpPr>
+          <p:cNvPr id="6" name="Shape 4"/>
+          <p:cNvSpPr/>
+          <p:nvPr/>
+        </p:nvSpPr>
+        <p:spPr>
+          <a:xfrm>
+            <a:off x="0" y="658368"/>
+            <a:ext cx="12191695" cy="0"/>
+          </a:xfrm>
+          <a:prstGeom prst="line">
+            <a:avLst/>
+          </a:prstGeom>
+          <a:noFill/>
+          <a:ln w="12700">
+            <a:solidFill>
+              <a:srgbClr val="E8006A"/>
+            </a:solidFill>
+            <a:prstDash val="solid"/>
+          </a:ln>
+        </p:spPr>
+      </p:sp>
+      <p:sp>
+        <p:nvSpPr>
+          <p:cNvPr id="7" name="Shape 5"/>
+          <p:cNvSpPr/>
+          <p:nvPr/>
+        </p:nvSpPr>
+        <p:spPr>
+          <a:xfrm>
+            <a:off x="0" y="621792"/>
+            <a:ext cx="12191695" cy="0"/>
+          </a:xfrm>
+          <a:prstGeom prst="line">
+            <a:avLst/>
+          </a:prstGeom>
+          <a:noFill/>
+          <a:ln w="12700">
+            <a:solidFill>
+              <a:srgbClr val="2A7D5B">
+                <a:alpha val="76000"/>
+              </a:srgbClr>
+            </a:solidFill>
+            <a:prstDash val="solid"/>
+          </a:ln>
+        </p:spPr>
+      </p:sp>
+      <p:sp>
+        <p:nvSpPr>
+          <p:cNvPr id="8" name="Text 6"/>
+          <p:cNvSpPr/>
+          <p:nvPr/>
+        </p:nvSpPr>
+        <p:spPr>
+          <a:xfrm>
+            <a:off x="457200" y="155448"/>
+            <a:ext cx="2560320" cy="274320"/>
+          </a:xfrm>
+          <a:prstGeom prst="rect">
+            <a:avLst/>
+          </a:prstGeom>
+          <a:noFill/>
+          <a:ln/>
+        </p:spPr>
+        <p:txBody>
+          <a:bodyPr wrap="square" rtlCol="0" anchor="ctr"/>
+          <a:lstStyle/>
+          <a:p>
+            <a:pPr indent="0" marL="0">
+              <a:buNone/>
+            </a:pPr>
+            <a:r>
+              <a:rPr lang="en-US" sz="1800" b="1" dirty="0">
+                <a:solidFill>
+                  <a:srgbClr val="FFFFFF"/>
+                </a:solidFill>
+                <a:latin typeface="Barlow Condensed" pitchFamily="34" charset="0"/>
+                <a:ea typeface="Barlow Condensed" pitchFamily="34" charset="-122"/>
+                <a:cs typeface="Barlow Condensed" pitchFamily="34" charset="-120"/>
+              </a:rPr>
+              <a:t>SOURCIER</a:t>
+            </a:r>
+            <a:endParaRPr lang="en-US" sz="1800" dirty="0"/>
+          </a:p>
+        </p:txBody>
+      </p:sp>
+      <p:sp>
+        <p:nvSpPr>
+          <p:cNvPr id="9" name="Text 7"/>
+          <p:cNvSpPr/>
+          <p:nvPr/>
+        </p:nvSpPr>
+        <p:spPr>
+          <a:xfrm>
+            <a:off x="457200" y="914400"/>
+            <a:ext cx="7863840" cy="685800"/>
+          </a:xfrm>
+          <a:prstGeom prst="rect">
+            <a:avLst/>
+          </a:prstGeom>
+          <a:noFill/>
+          <a:ln/>
+        </p:spPr>
+        <p:txBody>
+          <a:bodyPr wrap="square" rtlCol="0" anchor="ctr">
+            <a:normAutofit/>
+          </a:bodyPr>
+          <a:lstStyle/>
+          <a:p>
+            <a:pPr indent="0" marL="0">
+              <a:buNone/>
+            </a:pPr>
+            <a:r>
+              <a:rPr lang="en-US" sz="3400" b="1" dirty="0">
+                <a:solidFill>
+                  <a:srgbClr val="0F0F0F"/>
+                </a:solidFill>
+                <a:latin typeface="Barlow Condensed" pitchFamily="34" charset="0"/>
+                <a:ea typeface="Barlow Condensed" pitchFamily="34" charset="-122"/>
+                <a:cs typeface="Barlow Condensed" pitchFamily="34" charset="-120"/>
+              </a:rPr>
+              <a:t>IMAGE + CAPTION</a:t>
+            </a:r>
+            <a:endParaRPr lang="en-US" sz="3400" dirty="0"/>
+          </a:p>
+        </p:txBody>
+      </p:sp>
+      <p:sp>
+        <p:nvSpPr>
+          <p:cNvPr id="10" name="Text 8"/>
+          <p:cNvSpPr/>
+          <p:nvPr/>
+        </p:nvSpPr>
+        <p:spPr>
+          <a:xfrm>
+            <a:off x="457200" y="1600200"/>
+            <a:ext cx="8961120" cy="411480"/>
+          </a:xfrm>
+          <a:prstGeom prst="rect">
+            <a:avLst/>
+          </a:prstGeom>
+          <a:noFill/>
+          <a:ln/>
+        </p:spPr>
+        <p:txBody>
+          <a:bodyPr wrap="square" rtlCol="0" anchor="t"/>
+          <a:lstStyle/>
+          <a:p>
+            <a:pPr indent="0" marL="0">
+              <a:buNone/>
+            </a:pPr>
+            <a:r>
+              <a:rPr lang="en-US" sz="1800" dirty="0">
+                <a:solidFill>
+                  <a:srgbClr val="6B6B6B"/>
+                </a:solidFill>
+                <a:latin typeface="Barlow" pitchFamily="34" charset="0"/>
+                <a:ea typeface="Barlow" pitchFamily="34" charset="-122"/>
+                <a:cs typeface="Barlow" pitchFamily="34" charset="-120"/>
+              </a:rPr>
+              <a:t>Use for screenshots, architecture diagrams, or mockups.</a:t>
+            </a:r>
+            <a:endParaRPr lang="en-US" sz="1800" dirty="0"/>
+          </a:p>
+        </p:txBody>
+      </p:sp>
+      <p:sp>
+        <p:nvSpPr>
+          <p:cNvPr id="11" name="Shape 9"/>
+          <p:cNvSpPr/>
+          <p:nvPr/>
+        </p:nvSpPr>
+        <p:spPr>
+          <a:xfrm>
+            <a:off x="731520" y="2011680"/>
+            <a:ext cx="10744200" cy="3931920"/>
+          </a:xfrm>
+          <a:prstGeom prst="rect">
+            <a:avLst/>
+          </a:prstGeom>
+          <a:solidFill>
+            <a:srgbClr val="FFFAF4"/>
+          </a:solidFill>
+          <a:ln w="12700">
+            <a:solidFill>
+              <a:srgbClr val="D8C5AE"/>
+            </a:solidFill>
+            <a:prstDash val="solid"/>
+          </a:ln>
+        </p:spPr>
+      </p:sp>
+      <p:sp>
+        <p:nvSpPr>
+          <p:cNvPr id="12" name="Shape 10"/>
+          <p:cNvSpPr/>
+          <p:nvPr/>
+        </p:nvSpPr>
+        <p:spPr>
+          <a:xfrm>
+            <a:off x="731520" y="2011680"/>
+            <a:ext cx="10744200" cy="3931920"/>
+          </a:xfrm>
+          <a:prstGeom prst="line">
+            <a:avLst/>
+          </a:prstGeom>
+          <a:noFill/>
+          <a:ln w="12700">
+            <a:solidFill>
+              <a:srgbClr val="D7D7D7"/>
+            </a:solidFill>
+            <a:prstDash val="solid"/>
+          </a:ln>
+        </p:spPr>
+      </p:sp>
+      <p:sp>
+        <p:nvSpPr>
+          <p:cNvPr id="13" name="Shape 11"/>
+          <p:cNvSpPr/>
+          <p:nvPr/>
+        </p:nvSpPr>
+        <p:spPr>
+          <a:xfrm flipH="1">
+            <a:off x="731520" y="2011680"/>
+            <a:ext cx="10744200" cy="3931920"/>
+          </a:xfrm>
+          <a:prstGeom prst="line">
+            <a:avLst/>
+          </a:prstGeom>
+          <a:noFill/>
+          <a:ln w="12700">
+            <a:solidFill>
+              <a:srgbClr val="D7D7D7"/>
+            </a:solidFill>
+            <a:prstDash val="solid"/>
+          </a:ln>
+        </p:spPr>
+      </p:sp>
+      <p:sp>
+        <p:nvSpPr>
+          <p:cNvPr id="14" name="Text 12"/>
+          <p:cNvSpPr/>
+          <p:nvPr/>
+        </p:nvSpPr>
+        <p:spPr>
+          <a:xfrm>
+            <a:off x="4892040" y="3867912"/>
+            <a:ext cx="2423160" cy="274320"/>
+          </a:xfrm>
+          <a:prstGeom prst="rect">
+            <a:avLst/>
+          </a:prstGeom>
+          <a:noFill/>
+          <a:ln/>
+        </p:spPr>
+        <p:txBody>
+          <a:bodyPr wrap="square" rtlCol="0" anchor="ctr"/>
+          <a:lstStyle/>
+          <a:p>
+            <a:pPr algn="ctr" indent="0" marL="0">
+              <a:buNone/>
+            </a:pPr>
+            <a:r>
+              <a:rPr lang="en-US" sz="1400" dirty="0">
+                <a:solidFill>
+                  <a:srgbClr val="6B6B6B"/>
+                </a:solidFill>
+                <a:latin typeface="Barlow" pitchFamily="34" charset="0"/>
+                <a:ea typeface="Barlow" pitchFamily="34" charset="-122"/>
+                <a:cs typeface="Barlow" pitchFamily="34" charset="-120"/>
+              </a:rPr>
+              <a:t>Replace with screenshot or diagram</a:t>
+            </a:r>
+            <a:endParaRPr lang="en-US" sz="1400" dirty="0"/>
+          </a:p>
+        </p:txBody>
+      </p:sp>
+      <p:sp>
+        <p:nvSpPr>
+          <p:cNvPr id="15" name="Text 13"/>
+          <p:cNvSpPr/>
+          <p:nvPr/>
+        </p:nvSpPr>
+        <p:spPr>
+          <a:xfrm>
+            <a:off x="731520" y="6080760"/>
+            <a:ext cx="10744200" cy="320040"/>
+          </a:xfrm>
+          <a:prstGeom prst="rect">
+            <a:avLst/>
+          </a:prstGeom>
+          <a:noFill/>
+          <a:ln/>
+        </p:spPr>
+        <p:txBody>
+          <a:bodyPr wrap="square" rtlCol="0" anchor="ctr"/>
+          <a:lstStyle/>
+          <a:p>
+            <a:pPr indent="0" marL="0">
+              <a:buNone/>
+            </a:pPr>
+            <a:r>
+              <a:rPr lang="en-US" sz="1500" dirty="0">
+                <a:solidFill>
+                  <a:srgbClr val="6B6B6B"/>
+                </a:solidFill>
+                <a:latin typeface="Barlow" pitchFamily="34" charset="0"/>
+                <a:ea typeface="Barlow" pitchFamily="34" charset="-122"/>
+                <a:cs typeface="Barlow" pitchFamily="34" charset="-120"/>
+              </a:rPr>
+              <a:t>Caption: what this shows and why it matters.</a:t>
+            </a:r>
+            <a:endParaRPr lang="en-US" sz="1500" dirty="0"/>
+          </a:p>
+        </p:txBody>
+      </p:sp>
+      <p:sp>
+        <p:nvSpPr>
+          <p:cNvPr id="16" name="Shape 14"/>
+          <p:cNvSpPr/>
+          <p:nvPr/>
+        </p:nvSpPr>
+        <p:spPr>
+          <a:xfrm>
+            <a:off x="457200" y="6446520"/>
+            <a:ext cx="11277295" cy="0"/>
+          </a:xfrm>
+          <a:prstGeom prst="line">
+            <a:avLst/>
+          </a:prstGeom>
+          <a:noFill/>
+          <a:ln w="12700">
+            <a:solidFill>
+              <a:srgbClr val="D7D7D7"/>
+            </a:solidFill>
+            <a:prstDash val="solid"/>
+          </a:ln>
+        </p:spPr>
+      </p:sp>
+      <p:sp>
+        <p:nvSpPr>
+          <p:cNvPr id="17" name="Text 15"/>
+          <p:cNvSpPr/>
+          <p:nvPr/>
+        </p:nvSpPr>
+        <p:spPr>
+          <a:xfrm>
+            <a:off x="457200" y="6473952"/>
+            <a:ext cx="3657600" cy="182880"/>
+          </a:xfrm>
+          <a:prstGeom prst="rect">
+            <a:avLst/>
+          </a:prstGeom>
+          <a:noFill/>
+          <a:ln/>
+        </p:spPr>
+        <p:txBody>
+          <a:bodyPr wrap="square" rtlCol="0" anchor="ctr"/>
+          <a:lstStyle/>
+          <a:p>
+            <a:pPr indent="0" marL="0">
+              <a:buNone/>
+            </a:pPr>
+            <a:r>
+              <a:rPr lang="en-US" sz="1000" dirty="0">
+                <a:solidFill>
+                  <a:srgbClr val="6B6B6B"/>
+                </a:solidFill>
+                <a:latin typeface="Barlow" pitchFamily="34" charset="0"/>
+                <a:ea typeface="Barlow" pitchFamily="34" charset="-122"/>
+                <a:cs typeface="Barlow" pitchFamily="34" charset="-120"/>
+              </a:rPr>
+              <a:t>sourcier.uk</a:t>
+            </a:r>
+            <a:endParaRPr lang="en-US" sz="1000" dirty="0"/>
+          </a:p>
+        </p:txBody>
+      </p:sp>
+      <p:sp>
+        <p:nvSpPr>
+          <p:cNvPr id="18" name="Text 16"/>
+          <p:cNvSpPr/>
+          <p:nvPr/>
+        </p:nvSpPr>
+        <p:spPr>
+          <a:xfrm>
+            <a:off x="10744200" y="6473952"/>
+            <a:ext cx="1005840" cy="182880"/>
+          </a:xfrm>
+          <a:prstGeom prst="rect">
+            <a:avLst/>
+          </a:prstGeom>
+          <a:noFill/>
+          <a:ln/>
+        </p:spPr>
+        <p:txBody>
+          <a:bodyPr wrap="square" rtlCol="0" anchor="ctr"/>
+          <a:lstStyle/>
+          <a:p>
+            <a:pPr algn="r" indent="0" marL="0">
+              <a:buNone/>
+            </a:pPr>
+            <a:r>
+              <a:rPr lang="en-US" sz="1000" dirty="0">
+                <a:solidFill>
+                  <a:srgbClr val="6B6B6B"/>
+                </a:solidFill>
+                <a:latin typeface="Barlow" pitchFamily="34" charset="0"/>
+                <a:ea typeface="Barlow" pitchFamily="34" charset="-122"/>
+                <a:cs typeface="Barlow" pitchFamily="34" charset="-120"/>
+              </a:rPr>
+              <a:t>[slide number]</a:t>
+            </a:r>
+            <a:endParaRPr lang="en-US" sz="1000" dirty="0"/>
+          </a:p>
+        </p:txBody>
+      </p:sp>
+    </p:spTree>
+  </p:cSld>
+  <p:clrMapOvr>
+    <a:masterClrMapping/>
+  </p:clrMapOvr>
+</p:sld>
+</file>
+
+<file path=ppt/slides/slide9.xml><?xml version="1.0" encoding="utf-8"?>
+<p:sld xmlns:a="http://schemas.openxmlformats.org/drawingml/2006/main" xmlns:r="http://schemas.openxmlformats.org/officeDocument/2006/relationships" xmlns:p="http://schemas.openxmlformats.org/presentationml/2006/main">
+  <p:cSld name="Slide 9">
     <p:bg>
       <p:bgPr>
         <a:solidFill>

</xml_diff>